<commit_message>
Update slides: keep ITERATE call with accurate final metrics
Align recommendation with Huimin’s ITERATE choice, replace stale
placeholder bullets, and sync the 7-slide outline.

Co-authored-by: Cursor <cursoragent@cursor.com>
</commit_message>
<xml_diff>
--- a/docs/Group2_GenZ_Slang_Translator_Slides.pptx
+++ b/docs/Group2_GenZ_Slang_Translator_Slides.pptx
@@ -11,6 +11,7 @@
     <p:sldId id="259" r:id="rId10"/>
     <p:sldId id="260" r:id="rId11"/>
     <p:sldId id="261" r:id="rId12"/>
+    <p:sldId id="262" r:id="rId13"/>
   </p:sldIdLst>
   <p:sldSz cx="12191695" cy="6858000" type="screen4x3"/>
   <p:notesSz cx="6858000" cy="9144000"/>
@@ -3788,7 +3789,7 @@
         <p:spPr>
           <a:xfrm>
             <a:off x="457200" y="6492240"/>
-            <a:ext cx="7315200" cy="274320"/>
+            <a:ext cx="8229600" cy="274320"/>
           </a:xfrm>
           <a:prstGeom prst="rect">
             <a:avLst/>
@@ -3822,8 +3823,8 @@
         </p:nvSpPr>
         <p:spPr>
           <a:xfrm>
-            <a:off x="10515600" y="6492240"/>
-            <a:ext cx="1188720" cy="274320"/>
+            <a:off x="10332720" y="6492240"/>
+            <a:ext cx="1371600" cy="274320"/>
           </a:xfrm>
           <a:prstGeom prst="rect">
             <a:avLst/>
@@ -3844,7 +3845,7 @@
                 </a:solidFill>
                 <a:latin typeface="Calibri"/>
               </a:rPr>
-              <a:t>1 / 6</a:t>
+              <a:t>1 / 7</a:t>
             </a:r>
           </a:p>
         </p:txBody>
@@ -4281,7 +4282,7 @@
         <p:spPr>
           <a:xfrm>
             <a:off x="457200" y="6492240"/>
-            <a:ext cx="7315200" cy="274320"/>
+            <a:ext cx="8229600" cy="274320"/>
           </a:xfrm>
           <a:prstGeom prst="rect">
             <a:avLst/>
@@ -4315,8 +4316,8 @@
         </p:nvSpPr>
         <p:spPr>
           <a:xfrm>
-            <a:off x="10515600" y="6492240"/>
-            <a:ext cx="1188720" cy="274320"/>
+            <a:off x="10332720" y="6492240"/>
+            <a:ext cx="1371600" cy="274320"/>
           </a:xfrm>
           <a:prstGeom prst="rect">
             <a:avLst/>
@@ -4337,7 +4338,7 @@
                 </a:solidFill>
                 <a:latin typeface="Calibri"/>
               </a:rPr>
-              <a:t>2 / 6</a:t>
+              <a:t>2 / 7</a:t>
             </a:r>
           </a:p>
         </p:txBody>
@@ -5330,7 +5331,7 @@
         <p:spPr>
           <a:xfrm>
             <a:off x="457200" y="6492240"/>
-            <a:ext cx="7315200" cy="274320"/>
+            <a:ext cx="8229600" cy="274320"/>
           </a:xfrm>
           <a:prstGeom prst="rect">
             <a:avLst/>
@@ -5364,8 +5365,8 @@
         </p:nvSpPr>
         <p:spPr>
           <a:xfrm>
-            <a:off x="10515600" y="6492240"/>
-            <a:ext cx="1188720" cy="274320"/>
+            <a:off x="10332720" y="6492240"/>
+            <a:ext cx="1371600" cy="274320"/>
           </a:xfrm>
           <a:prstGeom prst="rect">
             <a:avLst/>
@@ -5386,7 +5387,7 @@
                 </a:solidFill>
                 <a:latin typeface="Calibri"/>
               </a:rPr>
-              <a:t>3 / 6</a:t>
+              <a:t>3 / 7</a:t>
             </a:r>
           </a:p>
         </p:txBody>
@@ -6590,7 +6591,7 @@
         <p:spPr>
           <a:xfrm>
             <a:off x="457200" y="6492240"/>
-            <a:ext cx="7315200" cy="274320"/>
+            <a:ext cx="8229600" cy="274320"/>
           </a:xfrm>
           <a:prstGeom prst="rect">
             <a:avLst/>
@@ -6624,8 +6625,8 @@
         </p:nvSpPr>
         <p:spPr>
           <a:xfrm>
-            <a:off x="10515600" y="6492240"/>
-            <a:ext cx="1188720" cy="274320"/>
+            <a:off x="10332720" y="6492240"/>
+            <a:ext cx="1371600" cy="274320"/>
           </a:xfrm>
           <a:prstGeom prst="rect">
             <a:avLst/>
@@ -6646,7 +6647,7 @@
                 </a:solidFill>
                 <a:latin typeface="Calibri"/>
               </a:rPr>
-              <a:t>4 / 6</a:t>
+              <a:t>4 / 7</a:t>
             </a:r>
           </a:p>
         </p:txBody>
@@ -6902,7 +6903,7 @@
                 </a:solidFill>
                 <a:latin typeface="Calibri"/>
               </a:rPr>
-              <a:t>Tuned answers are often too plain, wrong slang, or off-register vs the gold sentence.</a:t>
+              <a:t>Tuned often emits acronym junk (e.g. SIR, YLYITN, TNTF) instead of a slang sentence.</a:t>
             </a:r>
           </a:p>
           <a:p>
@@ -6918,7 +6919,7 @@
                 </a:solidFill>
                 <a:latin typeface="Calibri"/>
               </a:rPr>
-              <a:t>Open-ended direction + one reference string; decode tightened toward short outputs.</a:t>
+              <a:t>Avg length English→slang: base ~10 words, tuned ~3.5 — not gradable as translation.</a:t>
             </a:r>
           </a:p>
           <a:p>
@@ -6934,7 +6935,7 @@
                 </a:solidFill>
                 <a:latin typeface="Calibri"/>
               </a:rPr>
-              <a:t>Why: training mixture + inference constraints hurt this direction more than they helped.</a:t>
+              <a:t>Why: data + tight decode taught “slang = short codes.”</a:t>
             </a:r>
           </a:p>
         </p:txBody>
@@ -7012,7 +7013,7 @@
                 </a:solidFill>
                 <a:latin typeface="Calibri"/>
               </a:rPr>
-              <a:t>2 · Rare acronyms still missed</a:t>
+              <a:t>2 · Rare acronyms / wrong sense still missed</a:t>
             </a:r>
           </a:p>
         </p:txBody>
@@ -7067,7 +7068,7 @@
                 </a:solidFill>
                 <a:latin typeface="Calibri"/>
               </a:rPr>
-              <a:t>TUNED: "Good night everyone!" — drops TNT; generic farewell.</a:t>
+              <a:t>TUNED: "Good night everyone!" or "TNTF" — drops or mangles the sense.</a:t>
             </a:r>
           </a:p>
           <a:p>
@@ -7083,7 +7084,7 @@
                 </a:solidFill>
                 <a:latin typeface="Calibri"/>
               </a:rPr>
-              <a:t>Why: sparse signal for uncommon acronyms; falls back to polite chat.</a:t>
+              <a:t>Slang→English flat at 37%: fine-tune did not clearly beat base paraphrase.</a:t>
             </a:r>
           </a:p>
         </p:txBody>
@@ -7097,7 +7098,7 @@
         <p:spPr>
           <a:xfrm>
             <a:off x="457200" y="6492240"/>
-            <a:ext cx="7315200" cy="274320"/>
+            <a:ext cx="8229600" cy="274320"/>
           </a:xfrm>
           <a:prstGeom prst="rect">
             <a:avLst/>
@@ -7131,8 +7132,8 @@
         </p:nvSpPr>
         <p:spPr>
           <a:xfrm>
-            <a:off x="10515600" y="6492240"/>
-            <a:ext cx="1188720" cy="274320"/>
+            <a:off x="10332720" y="6492240"/>
+            <a:ext cx="1371600" cy="274320"/>
           </a:xfrm>
           <a:prstGeom prst="rect">
             <a:avLst/>
@@ -7153,7 +7154,7 @@
                 </a:solidFill>
                 <a:latin typeface="Calibri"/>
               </a:rPr>
-              <a:t>5 / 6</a:t>
+              <a:t>5 / 7</a:t>
             </a:r>
           </a:p>
         </p:txBody>
@@ -7270,7 +7271,7 @@
         </p:nvSpPr>
         <p:spPr>
           <a:xfrm>
-            <a:off x="502920" y="320040"/>
+            <a:off x="502920" y="274320"/>
             <a:ext cx="10972800" cy="457200"/>
           </a:xfrm>
           <a:prstGeom prst="rect">
@@ -7292,21 +7293,56 @@
                 </a:solidFill>
                 <a:latin typeface="Georgia"/>
               </a:rPr>
-              <a:t>Recommendation: HOLD</a:t>
-            </a:r>
-          </a:p>
-        </p:txBody>
-      </p:sp>
-      <p:sp>
-        <p:nvSpPr>
-          <p:cNvPr id="5" name="Rectangle 4"/>
+              <a:t>Why slang translation is so tricky</a:t>
+            </a:r>
+          </a:p>
+        </p:txBody>
+      </p:sp>
+      <p:sp>
+        <p:nvSpPr>
+          <p:cNvPr id="5" name="TextBox 4"/>
+          <p:cNvSpPr txBox="1"/>
+          <p:nvPr/>
+        </p:nvSpPr>
+        <p:spPr>
+          <a:xfrm>
+            <a:off x="502920" y="822960"/>
+            <a:ext cx="10972800" cy="320040"/>
+          </a:xfrm>
+          <a:prstGeom prst="rect">
+            <a:avLst/>
+          </a:prstGeom>
+          <a:noFill/>
+        </p:spPr>
+        <p:txBody>
+          <a:bodyPr wrap="square">
+            <a:spAutoFit/>
+          </a:bodyPr>
+          <a:lstStyle/>
+          <a:p>
+            <a:pPr algn="l"/>
+            <a:r>
+              <a:rPr sz="1500" b="0">
+                <a:solidFill>
+                  <a:srgbClr val="5C6B7A"/>
+                </a:solidFill>
+                <a:latin typeface="Calibri"/>
+              </a:rPr>
+              <a:t>Small knobs change the whole story — this is the nature of the task, not just “bad luck.”</a:t>
+            </a:r>
+          </a:p>
+        </p:txBody>
+      </p:sp>
+      <p:sp>
+        <p:nvSpPr>
+          <p:cNvPr id="6" name="Rectangle 5"/>
           <p:cNvSpPr/>
           <p:nvPr/>
         </p:nvSpPr>
         <p:spPr>
           <a:xfrm>
-            <a:off x="502920" y="1051560"/>
-            <a:ext cx="3566160" cy="914400"/>
+            <a:off x="502920" y="1280160"/>
+            <a:ext cx="3657600" cy="2148840"/>
           </a:xfrm>
           <a:prstGeom prst="rect">
             <a:avLst/>
@@ -7342,14 +7378,57 @@
       </p:sp>
       <p:sp>
         <p:nvSpPr>
-          <p:cNvPr id="6" name="TextBox 5"/>
+          <p:cNvPr id="7" name="Rectangle 6"/>
+          <p:cNvSpPr/>
+          <p:nvPr/>
+        </p:nvSpPr>
+        <p:spPr>
+          <a:xfrm>
+            <a:off x="502920" y="1280160"/>
+            <a:ext cx="109728" cy="2148840"/>
+          </a:xfrm>
+          <a:prstGeom prst="rect">
+            <a:avLst/>
+          </a:prstGeom>
+          <a:solidFill>
+            <a:srgbClr val="E85D04"/>
+          </a:solidFill>
+          <a:ln>
+            <a:noFill/>
+          </a:ln>
+        </p:spPr>
+        <p:style>
+          <a:lnRef idx="1">
+            <a:schemeClr val="accent1"/>
+          </a:lnRef>
+          <a:fillRef idx="3">
+            <a:schemeClr val="accent1"/>
+          </a:fillRef>
+          <a:effectRef idx="2">
+            <a:schemeClr val="accent1"/>
+          </a:effectRef>
+          <a:fontRef idx="minor">
+            <a:schemeClr val="lt1"/>
+          </a:fontRef>
+        </p:style>
+        <p:txBody>
+          <a:bodyPr rtlCol="0" anchor="ctr"/>
+          <a:lstStyle/>
+          <a:p>
+            <a:pPr algn="ctr"/>
+          </a:p>
+        </p:txBody>
+      </p:sp>
+      <p:sp>
+        <p:nvSpPr>
+          <p:cNvPr id="8" name="TextBox 7"/>
           <p:cNvSpPr txBox="1"/>
           <p:nvPr/>
         </p:nvSpPr>
         <p:spPr>
           <a:xfrm>
-            <a:off x="502920" y="1234440"/>
-            <a:ext cx="3566160" cy="548640"/>
+            <a:off x="777240" y="1463039"/>
+            <a:ext cx="3200400" cy="411480"/>
           </a:xfrm>
           <a:prstGeom prst="rect">
             <a:avLst/>
@@ -7362,29 +7441,64 @@
           </a:bodyPr>
           <a:lstStyle/>
           <a:p>
-            <a:pPr algn="ctr"/>
-            <a:r>
-              <a:rPr sz="2000" b="1">
-                <a:solidFill>
-                  <a:srgbClr val="5C6B7A"/>
-                </a:solidFill>
-                <a:latin typeface="Calibri"/>
-              </a:rPr>
-              <a:t>DEPLOY</a:t>
-            </a:r>
-          </a:p>
-        </p:txBody>
-      </p:sp>
-      <p:sp>
-        <p:nvSpPr>
-          <p:cNvPr id="7" name="Rectangle 6"/>
+            <a:pPr algn="l"/>
+            <a:r>
+              <a:rPr sz="1500" b="1">
+                <a:solidFill>
+                  <a:srgbClr val="0F1C2E"/>
+                </a:solidFill>
+                <a:latin typeface="Calibri"/>
+              </a:rPr>
+              <a:t>Many valid answers</a:t>
+            </a:r>
+          </a:p>
+        </p:txBody>
+      </p:sp>
+      <p:sp>
+        <p:nvSpPr>
+          <p:cNvPr id="9" name="TextBox 8"/>
+          <p:cNvSpPr txBox="1"/>
+          <p:nvPr/>
+        </p:nvSpPr>
+        <p:spPr>
+          <a:xfrm>
+            <a:off x="777240" y="1965960"/>
+            <a:ext cx="3200400" cy="1280160"/>
+          </a:xfrm>
+          <a:prstGeom prst="rect">
+            <a:avLst/>
+          </a:prstGeom>
+          <a:noFill/>
+        </p:spPr>
+        <p:txBody>
+          <a:bodyPr wrap="square">
+            <a:spAutoFit/>
+          </a:bodyPr>
+          <a:lstStyle/>
+          <a:p>
+            <a:pPr algn="l"/>
+            <a:r>
+              <a:rPr sz="1300" b="0">
+                <a:solidFill>
+                  <a:srgbClr val="1A2B3C"/>
+                </a:solidFill>
+                <a:latin typeface="Calibri"/>
+              </a:rPr>
+              <a:t>Especially English→slang: GOAT / fire / ate can all be “right.” One gold string under-credits good paraphrases.</a:t>
+            </a:r>
+          </a:p>
+        </p:txBody>
+      </p:sp>
+      <p:sp>
+        <p:nvSpPr>
+          <p:cNvPr id="10" name="Rectangle 9"/>
           <p:cNvSpPr/>
           <p:nvPr/>
         </p:nvSpPr>
         <p:spPr>
           <a:xfrm>
-            <a:off x="4297680" y="1051560"/>
-            <a:ext cx="3566160" cy="914400"/>
+            <a:off x="4343400" y="1280160"/>
+            <a:ext cx="3657600" cy="2148840"/>
           </a:xfrm>
           <a:prstGeom prst="rect">
             <a:avLst/>
@@ -7420,14 +7534,57 @@
       </p:sp>
       <p:sp>
         <p:nvSpPr>
-          <p:cNvPr id="8" name="TextBox 7"/>
+          <p:cNvPr id="11" name="Rectangle 10"/>
+          <p:cNvSpPr/>
+          <p:nvPr/>
+        </p:nvSpPr>
+        <p:spPr>
+          <a:xfrm>
+            <a:off x="4343400" y="1280160"/>
+            <a:ext cx="109728" cy="2148840"/>
+          </a:xfrm>
+          <a:prstGeom prst="rect">
+            <a:avLst/>
+          </a:prstGeom>
+          <a:solidFill>
+            <a:srgbClr val="E85D04"/>
+          </a:solidFill>
+          <a:ln>
+            <a:noFill/>
+          </a:ln>
+        </p:spPr>
+        <p:style>
+          <a:lnRef idx="1">
+            <a:schemeClr val="accent1"/>
+          </a:lnRef>
+          <a:fillRef idx="3">
+            <a:schemeClr val="accent1"/>
+          </a:fillRef>
+          <a:effectRef idx="2">
+            <a:schemeClr val="accent1"/>
+          </a:effectRef>
+          <a:fontRef idx="minor">
+            <a:schemeClr val="lt1"/>
+          </a:fontRef>
+        </p:style>
+        <p:txBody>
+          <a:bodyPr rtlCol="0" anchor="ctr"/>
+          <a:lstStyle/>
+          <a:p>
+            <a:pPr algn="ctr"/>
+          </a:p>
+        </p:txBody>
+      </p:sp>
+      <p:sp>
+        <p:nvSpPr>
+          <p:cNvPr id="12" name="TextBox 11"/>
           <p:cNvSpPr txBox="1"/>
           <p:nvPr/>
         </p:nvSpPr>
         <p:spPr>
           <a:xfrm>
-            <a:off x="4297680" y="1234440"/>
-            <a:ext cx="3566160" cy="548640"/>
+            <a:off x="4617720" y="1463039"/>
+            <a:ext cx="3200400" cy="411480"/>
           </a:xfrm>
           <a:prstGeom prst="rect">
             <a:avLst/>
@@ -7440,29 +7597,263 @@
           </a:bodyPr>
           <a:lstStyle/>
           <a:p>
+            <a:pPr algn="l"/>
+            <a:r>
+              <a:rPr sz="1500" b="1">
+                <a:solidFill>
+                  <a:srgbClr val="0F1C2E"/>
+                </a:solidFill>
+                <a:latin typeface="Calibri"/>
+              </a:rPr>
+              <a:t>Meaning ≠ surface form</a:t>
+            </a:r>
+          </a:p>
+        </p:txBody>
+      </p:sp>
+      <p:sp>
+        <p:nvSpPr>
+          <p:cNvPr id="13" name="TextBox 12"/>
+          <p:cNvSpPr txBox="1"/>
+          <p:nvPr/>
+        </p:nvSpPr>
+        <p:spPr>
+          <a:xfrm>
+            <a:off x="4617720" y="1965960"/>
+            <a:ext cx="3200400" cy="1280160"/>
+          </a:xfrm>
+          <a:prstGeom prst="rect">
+            <a:avLst/>
+          </a:prstGeom>
+          <a:noFill/>
+        </p:spPr>
+        <p:txBody>
+          <a:bodyPr wrap="square">
+            <a:spAutoFit/>
+          </a:bodyPr>
+          <a:lstStyle/>
+          <a:p>
+            <a:pPr algn="l"/>
+            <a:r>
+              <a:rPr sz="1300" b="0">
+                <a:solidFill>
+                  <a:srgbClr val="1A2B3C"/>
+                </a:solidFill>
+                <a:latin typeface="Calibri"/>
+              </a:rPr>
+              <a:t>Humans score sense. Decode length + prompts change what the model emits overnight (essays ↔ acronym soup).</a:t>
+            </a:r>
+          </a:p>
+        </p:txBody>
+      </p:sp>
+      <p:sp>
+        <p:nvSpPr>
+          <p:cNvPr id="14" name="Rectangle 13"/>
+          <p:cNvSpPr/>
+          <p:nvPr/>
+        </p:nvSpPr>
+        <p:spPr>
+          <a:xfrm>
+            <a:off x="8183880" y="1280160"/>
+            <a:ext cx="3657600" cy="2148840"/>
+          </a:xfrm>
+          <a:prstGeom prst="rect">
+            <a:avLst/>
+          </a:prstGeom>
+          <a:solidFill>
+            <a:srgbClr val="FFFFFF"/>
+          </a:solidFill>
+          <a:ln>
+            <a:noFill/>
+          </a:ln>
+        </p:spPr>
+        <p:style>
+          <a:lnRef idx="1">
+            <a:schemeClr val="accent1"/>
+          </a:lnRef>
+          <a:fillRef idx="3">
+            <a:schemeClr val="accent1"/>
+          </a:fillRef>
+          <a:effectRef idx="2">
+            <a:schemeClr val="accent1"/>
+          </a:effectRef>
+          <a:fontRef idx="minor">
+            <a:schemeClr val="lt1"/>
+          </a:fontRef>
+        </p:style>
+        <p:txBody>
+          <a:bodyPr rtlCol="0" anchor="ctr"/>
+          <a:lstStyle/>
+          <a:p>
             <a:pPr algn="ctr"/>
-            <a:r>
-              <a:rPr sz="2000" b="1">
-                <a:solidFill>
-                  <a:srgbClr val="5C6B7A"/>
-                </a:solidFill>
-                <a:latin typeface="Calibri"/>
-              </a:rPr>
-              <a:t>ITERATE</a:t>
-            </a:r>
-          </a:p>
-        </p:txBody>
-      </p:sp>
-      <p:sp>
-        <p:nvSpPr>
-          <p:cNvPr id="9" name="Rectangle 8"/>
+          </a:p>
+        </p:txBody>
+      </p:sp>
+      <p:sp>
+        <p:nvSpPr>
+          <p:cNvPr id="15" name="Rectangle 14"/>
           <p:cNvSpPr/>
           <p:nvPr/>
         </p:nvSpPr>
         <p:spPr>
           <a:xfrm>
-            <a:off x="8092440" y="1051560"/>
-            <a:ext cx="3566160" cy="914400"/>
+            <a:off x="8183880" y="1280160"/>
+            <a:ext cx="109728" cy="2148840"/>
+          </a:xfrm>
+          <a:prstGeom prst="rect">
+            <a:avLst/>
+          </a:prstGeom>
+          <a:solidFill>
+            <a:srgbClr val="E85D04"/>
+          </a:solidFill>
+          <a:ln>
+            <a:noFill/>
+          </a:ln>
+        </p:spPr>
+        <p:style>
+          <a:lnRef idx="1">
+            <a:schemeClr val="accent1"/>
+          </a:lnRef>
+          <a:fillRef idx="3">
+            <a:schemeClr val="accent1"/>
+          </a:fillRef>
+          <a:effectRef idx="2">
+            <a:schemeClr val="accent1"/>
+          </a:effectRef>
+          <a:fontRef idx="minor">
+            <a:schemeClr val="lt1"/>
+          </a:fontRef>
+        </p:style>
+        <p:txBody>
+          <a:bodyPr rtlCol="0" anchor="ctr"/>
+          <a:lstStyle/>
+          <a:p>
+            <a:pPr algn="ctr"/>
+          </a:p>
+        </p:txBody>
+      </p:sp>
+      <p:sp>
+        <p:nvSpPr>
+          <p:cNvPr id="16" name="TextBox 15"/>
+          <p:cNvSpPr txBox="1"/>
+          <p:nvPr/>
+        </p:nvSpPr>
+        <p:spPr>
+          <a:xfrm>
+            <a:off x="8458200" y="1463039"/>
+            <a:ext cx="3200400" cy="411480"/>
+          </a:xfrm>
+          <a:prstGeom prst="rect">
+            <a:avLst/>
+          </a:prstGeom>
+          <a:noFill/>
+        </p:spPr>
+        <p:txBody>
+          <a:bodyPr wrap="square">
+            <a:spAutoFit/>
+          </a:bodyPr>
+          <a:lstStyle/>
+          <a:p>
+            <a:pPr algn="l"/>
+            <a:r>
+              <a:rPr sz="1500" b="1">
+                <a:solidFill>
+                  <a:srgbClr val="0F1C2E"/>
+                </a:solidFill>
+                <a:latin typeface="Calibri"/>
+              </a:rPr>
+              <a:t>Data style leaks</a:t>
+            </a:r>
+          </a:p>
+        </p:txBody>
+      </p:sp>
+      <p:sp>
+        <p:nvSpPr>
+          <p:cNvPr id="17" name="TextBox 16"/>
+          <p:cNvSpPr txBox="1"/>
+          <p:nvPr/>
+        </p:nvSpPr>
+        <p:spPr>
+          <a:xfrm>
+            <a:off x="8458200" y="1965960"/>
+            <a:ext cx="3200400" cy="1280160"/>
+          </a:xfrm>
+          <a:prstGeom prst="rect">
+            <a:avLst/>
+          </a:prstGeom>
+          <a:noFill/>
+        </p:spPr>
+        <p:txBody>
+          <a:bodyPr wrap="square">
+            <a:spAutoFit/>
+          </a:bodyPr>
+          <a:lstStyle/>
+          <a:p>
+            <a:pPr algn="l"/>
+            <a:r>
+              <a:rPr sz="1300" b="0">
+                <a:solidFill>
+                  <a:srgbClr val="1A2B3C"/>
+                </a:solidFill>
+                <a:latin typeface="Calibri"/>
+              </a:rPr>
+              <a:t>Dict / acronym-heavy pairs quietly teach TNTF-style junk. Training mix becomes behaviour.</a:t>
+            </a:r>
+          </a:p>
+        </p:txBody>
+      </p:sp>
+      <p:sp>
+        <p:nvSpPr>
+          <p:cNvPr id="18" name="Rectangle 17"/>
+          <p:cNvSpPr/>
+          <p:nvPr/>
+        </p:nvSpPr>
+        <p:spPr>
+          <a:xfrm>
+            <a:off x="502920" y="3611879"/>
+            <a:ext cx="3657600" cy="2148840"/>
+          </a:xfrm>
+          <a:prstGeom prst="rect">
+            <a:avLst/>
+          </a:prstGeom>
+          <a:solidFill>
+            <a:srgbClr val="FFFFFF"/>
+          </a:solidFill>
+          <a:ln>
+            <a:noFill/>
+          </a:ln>
+        </p:spPr>
+        <p:style>
+          <a:lnRef idx="1">
+            <a:schemeClr val="accent1"/>
+          </a:lnRef>
+          <a:fillRef idx="3">
+            <a:schemeClr val="accent1"/>
+          </a:fillRef>
+          <a:effectRef idx="2">
+            <a:schemeClr val="accent1"/>
+          </a:effectRef>
+          <a:fontRef idx="minor">
+            <a:schemeClr val="lt1"/>
+          </a:fontRef>
+        </p:style>
+        <p:txBody>
+          <a:bodyPr rtlCol="0" anchor="ctr"/>
+          <a:lstStyle/>
+          <a:p>
+            <a:pPr algn="ctr"/>
+          </a:p>
+        </p:txBody>
+      </p:sp>
+      <p:sp>
+        <p:nvSpPr>
+          <p:cNvPr id="19" name="Rectangle 18"/>
+          <p:cNvSpPr/>
+          <p:nvPr/>
+        </p:nvSpPr>
+        <p:spPr>
+          <a:xfrm>
+            <a:off x="502920" y="3611879"/>
+            <a:ext cx="109728" cy="2148840"/>
           </a:xfrm>
           <a:prstGeom prst="rect">
             <a:avLst/>
@@ -7498,14 +7889,14 @@
       </p:sp>
       <p:sp>
         <p:nvSpPr>
-          <p:cNvPr id="10" name="TextBox 9"/>
+          <p:cNvPr id="20" name="TextBox 19"/>
           <p:cNvSpPr txBox="1"/>
           <p:nvPr/>
         </p:nvSpPr>
         <p:spPr>
           <a:xfrm>
-            <a:off x="8092440" y="1234440"/>
-            <a:ext cx="3566160" cy="548640"/>
+            <a:off x="777240" y="3794759"/>
+            <a:ext cx="3200400" cy="411480"/>
           </a:xfrm>
           <a:prstGeom prst="rect">
             <a:avLst/>
@@ -7518,15 +7909,805 @@
           </a:bodyPr>
           <a:lstStyle/>
           <a:p>
+            <a:pPr algn="l"/>
+            <a:r>
+              <a:rPr sz="1500" b="1">
+                <a:solidFill>
+                  <a:srgbClr val="0F1C2E"/>
+                </a:solidFill>
+                <a:latin typeface="Calibri"/>
+              </a:rPr>
+              <a:t>Base is already decent</a:t>
+            </a:r>
+          </a:p>
+        </p:txBody>
+      </p:sp>
+      <p:sp>
+        <p:nvSpPr>
+          <p:cNvPr id="21" name="TextBox 20"/>
+          <p:cNvSpPr txBox="1"/>
+          <p:nvPr/>
+        </p:nvSpPr>
+        <p:spPr>
+          <a:xfrm>
+            <a:off x="777240" y="4297679"/>
+            <a:ext cx="3200400" cy="1280160"/>
+          </a:xfrm>
+          <a:prstGeom prst="rect">
+            <a:avLst/>
+          </a:prstGeom>
+          <a:noFill/>
+        </p:spPr>
+        <p:txBody>
+          <a:bodyPr wrap="square">
+            <a:spAutoFit/>
+          </a:bodyPr>
+          <a:lstStyle/>
+          <a:p>
+            <a:pPr algn="l"/>
+            <a:r>
+              <a:rPr sz="1300" b="0">
+                <a:solidFill>
+                  <a:srgbClr val="1A2B3C"/>
+                </a:solidFill>
+                <a:latin typeface="Calibri"/>
+              </a:rPr>
+              <a:t>Llama paraphrases OK. Fine-tuning can hurt a direction if the new habit is worse than the base.</a:t>
+            </a:r>
+          </a:p>
+        </p:txBody>
+      </p:sp>
+      <p:sp>
+        <p:nvSpPr>
+          <p:cNvPr id="22" name="Rectangle 21"/>
+          <p:cNvSpPr/>
+          <p:nvPr/>
+        </p:nvSpPr>
+        <p:spPr>
+          <a:xfrm>
+            <a:off x="4343400" y="3611879"/>
+            <a:ext cx="3657600" cy="2148840"/>
+          </a:xfrm>
+          <a:prstGeom prst="rect">
+            <a:avLst/>
+          </a:prstGeom>
+          <a:solidFill>
+            <a:srgbClr val="FFFFFF"/>
+          </a:solidFill>
+          <a:ln>
+            <a:noFill/>
+          </a:ln>
+        </p:spPr>
+        <p:style>
+          <a:lnRef idx="1">
+            <a:schemeClr val="accent1"/>
+          </a:lnRef>
+          <a:fillRef idx="3">
+            <a:schemeClr val="accent1"/>
+          </a:fillRef>
+          <a:effectRef idx="2">
+            <a:schemeClr val="accent1"/>
+          </a:effectRef>
+          <a:fontRef idx="minor">
+            <a:schemeClr val="lt1"/>
+          </a:fontRef>
+        </p:style>
+        <p:txBody>
+          <a:bodyPr rtlCol="0" anchor="ctr"/>
+          <a:lstStyle/>
+          <a:p>
             <a:pPr algn="ctr"/>
+          </a:p>
+        </p:txBody>
+      </p:sp>
+      <p:sp>
+        <p:nvSpPr>
+          <p:cNvPr id="23" name="Rectangle 22"/>
+          <p:cNvSpPr/>
+          <p:nvPr/>
+        </p:nvSpPr>
+        <p:spPr>
+          <a:xfrm>
+            <a:off x="4343400" y="3611879"/>
+            <a:ext cx="109728" cy="2148840"/>
+          </a:xfrm>
+          <a:prstGeom prst="rect">
+            <a:avLst/>
+          </a:prstGeom>
+          <a:solidFill>
+            <a:srgbClr val="0D9488"/>
+          </a:solidFill>
+          <a:ln>
+            <a:noFill/>
+          </a:ln>
+        </p:spPr>
+        <p:style>
+          <a:lnRef idx="1">
+            <a:schemeClr val="accent1"/>
+          </a:lnRef>
+          <a:fillRef idx="3">
+            <a:schemeClr val="accent1"/>
+          </a:fillRef>
+          <a:effectRef idx="2">
+            <a:schemeClr val="accent1"/>
+          </a:effectRef>
+          <a:fontRef idx="minor">
+            <a:schemeClr val="lt1"/>
+          </a:fontRef>
+        </p:style>
+        <p:txBody>
+          <a:bodyPr rtlCol="0" anchor="ctr"/>
+          <a:lstStyle/>
+          <a:p>
+            <a:pPr algn="ctr"/>
+          </a:p>
+        </p:txBody>
+      </p:sp>
+      <p:sp>
+        <p:nvSpPr>
+          <p:cNvPr id="24" name="TextBox 23"/>
+          <p:cNvSpPr txBox="1"/>
+          <p:nvPr/>
+        </p:nvSpPr>
+        <p:spPr>
+          <a:xfrm>
+            <a:off x="4617720" y="3794759"/>
+            <a:ext cx="3200400" cy="411480"/>
+          </a:xfrm>
+          <a:prstGeom prst="rect">
+            <a:avLst/>
+          </a:prstGeom>
+          <a:noFill/>
+        </p:spPr>
+        <p:txBody>
+          <a:bodyPr wrap="square">
+            <a:spAutoFit/>
+          </a:bodyPr>
+          <a:lstStyle/>
+          <a:p>
+            <a:pPr algn="l"/>
+            <a:r>
+              <a:rPr sz="1500" b="1">
+                <a:solidFill>
+                  <a:srgbClr val="0F1C2E"/>
+                </a:solidFill>
+                <a:latin typeface="Calibri"/>
+              </a:rPr>
+              <a:t>Eval design matters</a:t>
+            </a:r>
+          </a:p>
+        </p:txBody>
+      </p:sp>
+      <p:sp>
+        <p:nvSpPr>
+          <p:cNvPr id="25" name="TextBox 24"/>
+          <p:cNvSpPr txBox="1"/>
+          <p:nvPr/>
+        </p:nvSpPr>
+        <p:spPr>
+          <a:xfrm>
+            <a:off x="4617720" y="4297679"/>
+            <a:ext cx="3200400" cy="1280160"/>
+          </a:xfrm>
+          <a:prstGeom prst="rect">
+            <a:avLst/>
+          </a:prstGeom>
+          <a:noFill/>
+        </p:spPr>
+        <p:txBody>
+          <a:bodyPr wrap="square">
+            <a:spAutoFit/>
+          </a:bodyPr>
+          <a:lstStyle/>
+          <a:p>
+            <a:pPr algn="l"/>
+            <a:r>
+              <a:rPr sz="1300" b="0">
+                <a:solidFill>
+                  <a:srgbClr val="1A2B3C"/>
+                </a:solidFill>
+                <a:latin typeface="Calibri"/>
+              </a:rPr>
+              <a:t>Gloss-style eval looked strong; natural held-out eval told the truth. Metric choice can hide failure.</a:t>
+            </a:r>
+          </a:p>
+        </p:txBody>
+      </p:sp>
+      <p:sp>
+        <p:nvSpPr>
+          <p:cNvPr id="26" name="Rectangle 25"/>
+          <p:cNvSpPr/>
+          <p:nvPr/>
+        </p:nvSpPr>
+        <p:spPr>
+          <a:xfrm>
+            <a:off x="8183880" y="3611879"/>
+            <a:ext cx="3657600" cy="2148840"/>
+          </a:xfrm>
+          <a:prstGeom prst="rect">
+            <a:avLst/>
+          </a:prstGeom>
+          <a:solidFill>
+            <a:srgbClr val="FFFFFF"/>
+          </a:solidFill>
+          <a:ln>
+            <a:noFill/>
+          </a:ln>
+        </p:spPr>
+        <p:style>
+          <a:lnRef idx="1">
+            <a:schemeClr val="accent1"/>
+          </a:lnRef>
+          <a:fillRef idx="3">
+            <a:schemeClr val="accent1"/>
+          </a:fillRef>
+          <a:effectRef idx="2">
+            <a:schemeClr val="accent1"/>
+          </a:effectRef>
+          <a:fontRef idx="minor">
+            <a:schemeClr val="lt1"/>
+          </a:fontRef>
+        </p:style>
+        <p:txBody>
+          <a:bodyPr rtlCol="0" anchor="ctr"/>
+          <a:lstStyle/>
+          <a:p>
+            <a:pPr algn="ctr"/>
+          </a:p>
+        </p:txBody>
+      </p:sp>
+      <p:sp>
+        <p:nvSpPr>
+          <p:cNvPr id="27" name="Rectangle 26"/>
+          <p:cNvSpPr/>
+          <p:nvPr/>
+        </p:nvSpPr>
+        <p:spPr>
+          <a:xfrm>
+            <a:off x="8183880" y="3611879"/>
+            <a:ext cx="109728" cy="2148840"/>
+          </a:xfrm>
+          <a:prstGeom prst="rect">
+            <a:avLst/>
+          </a:prstGeom>
+          <a:solidFill>
+            <a:srgbClr val="0D9488"/>
+          </a:solidFill>
+          <a:ln>
+            <a:noFill/>
+          </a:ln>
+        </p:spPr>
+        <p:style>
+          <a:lnRef idx="1">
+            <a:schemeClr val="accent1"/>
+          </a:lnRef>
+          <a:fillRef idx="3">
+            <a:schemeClr val="accent1"/>
+          </a:fillRef>
+          <a:effectRef idx="2">
+            <a:schemeClr val="accent1"/>
+          </a:effectRef>
+          <a:fontRef idx="minor">
+            <a:schemeClr val="lt1"/>
+          </a:fontRef>
+        </p:style>
+        <p:txBody>
+          <a:bodyPr rtlCol="0" anchor="ctr"/>
+          <a:lstStyle/>
+          <a:p>
+            <a:pPr algn="ctr"/>
+          </a:p>
+        </p:txBody>
+      </p:sp>
+      <p:sp>
+        <p:nvSpPr>
+          <p:cNvPr id="28" name="TextBox 27"/>
+          <p:cNvSpPr txBox="1"/>
+          <p:nvPr/>
+        </p:nvSpPr>
+        <p:spPr>
+          <a:xfrm>
+            <a:off x="8458200" y="3794759"/>
+            <a:ext cx="3200400" cy="411480"/>
+          </a:xfrm>
+          <a:prstGeom prst="rect">
+            <a:avLst/>
+          </a:prstGeom>
+          <a:noFill/>
+        </p:spPr>
+        <p:txBody>
+          <a:bodyPr wrap="square">
+            <a:spAutoFit/>
+          </a:bodyPr>
+          <a:lstStyle/>
+          <a:p>
+            <a:pPr algn="l"/>
+            <a:r>
+              <a:rPr sz="1500" b="1">
+                <a:solidFill>
+                  <a:srgbClr val="0F1C2E"/>
+                </a:solidFill>
+                <a:latin typeface="Calibri"/>
+              </a:rPr>
+              <a:t>Two directions ≠ one skill</a:t>
+            </a:r>
+          </a:p>
+        </p:txBody>
+      </p:sp>
+      <p:sp>
+        <p:nvSpPr>
+          <p:cNvPr id="29" name="TextBox 28"/>
+          <p:cNvSpPr txBox="1"/>
+          <p:nvPr/>
+        </p:nvSpPr>
+        <p:spPr>
+          <a:xfrm>
+            <a:off x="8458200" y="4297679"/>
+            <a:ext cx="3200400" cy="1280160"/>
+          </a:xfrm>
+          <a:prstGeom prst="rect">
+            <a:avLst/>
+          </a:prstGeom>
+          <a:noFill/>
+        </p:spPr>
+        <p:txBody>
+          <a:bodyPr wrap="square">
+            <a:spAutoFit/>
+          </a:bodyPr>
+          <a:lstStyle/>
+          <a:p>
+            <a:pPr algn="l"/>
+            <a:r>
+              <a:rPr sz="1300" b="0">
+                <a:solidFill>
+                  <a:srgbClr val="1A2B3C"/>
+                </a:solidFill>
+                <a:latin typeface="Calibri"/>
+              </a:rPr>
+              <a:t>Slang→English and English→slang fail differently. One adapter, two hard problems.</a:t>
+            </a:r>
+          </a:p>
+        </p:txBody>
+      </p:sp>
+      <p:sp>
+        <p:nvSpPr>
+          <p:cNvPr id="30" name="TextBox 29"/>
+          <p:cNvSpPr txBox="1"/>
+          <p:nvPr/>
+        </p:nvSpPr>
+        <p:spPr>
+          <a:xfrm>
+            <a:off x="457200" y="6492240"/>
+            <a:ext cx="8229600" cy="274320"/>
+          </a:xfrm>
+          <a:prstGeom prst="rect">
+            <a:avLst/>
+          </a:prstGeom>
+          <a:noFill/>
+        </p:spPr>
+        <p:txBody>
+          <a:bodyPr wrap="square">
+            <a:spAutoFit/>
+          </a:bodyPr>
+          <a:lstStyle/>
+          <a:p>
+            <a:pPr algn="l"/>
+            <a:r>
+              <a:rPr sz="1100" b="0">
+                <a:solidFill>
+                  <a:srgbClr val="5C6B7A"/>
+                </a:solidFill>
+                <a:latin typeface="Calibri"/>
+              </a:rPr>
+              <a:t>Group 2  ·  Week 5 Mini-project  ·  Speaker: Analysis</a:t>
+            </a:r>
+          </a:p>
+        </p:txBody>
+      </p:sp>
+      <p:sp>
+        <p:nvSpPr>
+          <p:cNvPr id="31" name="TextBox 30"/>
+          <p:cNvSpPr txBox="1"/>
+          <p:nvPr/>
+        </p:nvSpPr>
+        <p:spPr>
+          <a:xfrm>
+            <a:off x="10332720" y="6492240"/>
+            <a:ext cx="1371600" cy="274320"/>
+          </a:xfrm>
+          <a:prstGeom prst="rect">
+            <a:avLst/>
+          </a:prstGeom>
+          <a:noFill/>
+        </p:spPr>
+        <p:txBody>
+          <a:bodyPr wrap="square">
+            <a:spAutoFit/>
+          </a:bodyPr>
+          <a:lstStyle/>
+          <a:p>
+            <a:pPr algn="r"/>
+            <a:r>
+              <a:rPr sz="1100" b="0">
+                <a:solidFill>
+                  <a:srgbClr val="5C6B7A"/>
+                </a:solidFill>
+                <a:latin typeface="Calibri"/>
+              </a:rPr>
+              <a:t>6 / 7</a:t>
+            </a:r>
+          </a:p>
+        </p:txBody>
+      </p:sp>
+    </p:spTree>
+  </p:cSld>
+  <p:clrMapOvr>
+    <a:masterClrMapping/>
+  </p:clrMapOvr>
+</p:sld>
+</file>
+
+<file path=ppt/slides/slide7.xml><?xml version="1.0" encoding="utf-8"?>
+<p:sld xmlns:a="http://schemas.openxmlformats.org/drawingml/2006/main" xmlns:p="http://schemas.openxmlformats.org/presentationml/2006/main" xmlns:r="http://schemas.openxmlformats.org/officeDocument/2006/relationships">
+  <p:cSld>
+    <p:spTree>
+      <p:nvGrpSpPr>
+        <p:cNvPr id="1" name=""/>
+        <p:cNvGrpSpPr/>
+        <p:nvPr/>
+      </p:nvGrpSpPr>
+      <p:grpSpPr/>
+      <p:sp>
+        <p:nvSpPr>
+          <p:cNvPr id="2" name="Rectangle 1"/>
+          <p:cNvSpPr/>
+          <p:nvPr/>
+        </p:nvSpPr>
+        <p:spPr>
+          <a:xfrm>
+            <a:off x="0" y="0"/>
+            <a:ext cx="12191695" cy="6858000"/>
+          </a:xfrm>
+          <a:prstGeom prst="rect">
+            <a:avLst/>
+          </a:prstGeom>
+          <a:solidFill>
+            <a:srgbClr val="F7F4EF"/>
+          </a:solidFill>
+          <a:ln>
+            <a:noFill/>
+          </a:ln>
+        </p:spPr>
+        <p:style>
+          <a:lnRef idx="1">
+            <a:schemeClr val="accent1"/>
+          </a:lnRef>
+          <a:fillRef idx="3">
+            <a:schemeClr val="accent1"/>
+          </a:fillRef>
+          <a:effectRef idx="2">
+            <a:schemeClr val="accent1"/>
+          </a:effectRef>
+          <a:fontRef idx="minor">
+            <a:schemeClr val="lt1"/>
+          </a:fontRef>
+        </p:style>
+        <p:txBody>
+          <a:bodyPr rtlCol="0" anchor="ctr"/>
+          <a:lstStyle/>
+          <a:p>
+            <a:pPr algn="ctr"/>
+          </a:p>
+        </p:txBody>
+      </p:sp>
+      <p:sp>
+        <p:nvSpPr>
+          <p:cNvPr id="3" name="Rectangle 2"/>
+          <p:cNvSpPr/>
+          <p:nvPr/>
+        </p:nvSpPr>
+        <p:spPr>
+          <a:xfrm>
+            <a:off x="0" y="0"/>
+            <a:ext cx="109728" cy="6858000"/>
+          </a:xfrm>
+          <a:prstGeom prst="rect">
+            <a:avLst/>
+          </a:prstGeom>
+          <a:solidFill>
+            <a:srgbClr val="E85D04"/>
+          </a:solidFill>
+          <a:ln>
+            <a:noFill/>
+          </a:ln>
+        </p:spPr>
+        <p:style>
+          <a:lnRef idx="1">
+            <a:schemeClr val="accent1"/>
+          </a:lnRef>
+          <a:fillRef idx="3">
+            <a:schemeClr val="accent1"/>
+          </a:fillRef>
+          <a:effectRef idx="2">
+            <a:schemeClr val="accent1"/>
+          </a:effectRef>
+          <a:fontRef idx="minor">
+            <a:schemeClr val="lt1"/>
+          </a:fontRef>
+        </p:style>
+        <p:txBody>
+          <a:bodyPr rtlCol="0" anchor="ctr"/>
+          <a:lstStyle/>
+          <a:p>
+            <a:pPr algn="ctr"/>
+          </a:p>
+        </p:txBody>
+      </p:sp>
+      <p:sp>
+        <p:nvSpPr>
+          <p:cNvPr id="4" name="TextBox 3"/>
+          <p:cNvSpPr txBox="1"/>
+          <p:nvPr/>
+        </p:nvSpPr>
+        <p:spPr>
+          <a:xfrm>
+            <a:off x="502920" y="320040"/>
+            <a:ext cx="10972800" cy="457200"/>
+          </a:xfrm>
+          <a:prstGeom prst="rect">
+            <a:avLst/>
+          </a:prstGeom>
+          <a:noFill/>
+        </p:spPr>
+        <p:txBody>
+          <a:bodyPr wrap="square">
+            <a:spAutoFit/>
+          </a:bodyPr>
+          <a:lstStyle/>
+          <a:p>
+            <a:pPr algn="l"/>
+            <a:r>
+              <a:rPr sz="3000" b="1">
+                <a:solidFill>
+                  <a:srgbClr val="0F1C2E"/>
+                </a:solidFill>
+                <a:latin typeface="Georgia"/>
+              </a:rPr>
+              <a:t>Recommendation: ITERATE</a:t>
+            </a:r>
+          </a:p>
+        </p:txBody>
+      </p:sp>
+      <p:sp>
+        <p:nvSpPr>
+          <p:cNvPr id="5" name="Rectangle 4"/>
+          <p:cNvSpPr/>
+          <p:nvPr/>
+        </p:nvSpPr>
+        <p:spPr>
+          <a:xfrm>
+            <a:off x="502920" y="1051560"/>
+            <a:ext cx="3566160" cy="914400"/>
+          </a:xfrm>
+          <a:prstGeom prst="rect">
+            <a:avLst/>
+          </a:prstGeom>
+          <a:solidFill>
+            <a:srgbClr val="FFFFFF"/>
+          </a:solidFill>
+          <a:ln>
+            <a:noFill/>
+          </a:ln>
+        </p:spPr>
+        <p:style>
+          <a:lnRef idx="1">
+            <a:schemeClr val="accent1"/>
+          </a:lnRef>
+          <a:fillRef idx="3">
+            <a:schemeClr val="accent1"/>
+          </a:fillRef>
+          <a:effectRef idx="2">
+            <a:schemeClr val="accent1"/>
+          </a:effectRef>
+          <a:fontRef idx="minor">
+            <a:schemeClr val="lt1"/>
+          </a:fontRef>
+        </p:style>
+        <p:txBody>
+          <a:bodyPr rtlCol="0" anchor="ctr"/>
+          <a:lstStyle/>
+          <a:p>
+            <a:pPr algn="ctr"/>
+          </a:p>
+        </p:txBody>
+      </p:sp>
+      <p:sp>
+        <p:nvSpPr>
+          <p:cNvPr id="6" name="TextBox 5"/>
+          <p:cNvSpPr txBox="1"/>
+          <p:nvPr/>
+        </p:nvSpPr>
+        <p:spPr>
+          <a:xfrm>
+            <a:off x="502920" y="1234440"/>
+            <a:ext cx="3566160" cy="548640"/>
+          </a:xfrm>
+          <a:prstGeom prst="rect">
+            <a:avLst/>
+          </a:prstGeom>
+          <a:noFill/>
+        </p:spPr>
+        <p:txBody>
+          <a:bodyPr wrap="square">
+            <a:spAutoFit/>
+          </a:bodyPr>
+          <a:lstStyle/>
+          <a:p>
+            <a:pPr algn="ctr"/>
             <a:r>
               <a:rPr sz="2000" b="1">
                 <a:solidFill>
+                  <a:srgbClr val="5C6B7A"/>
+                </a:solidFill>
+                <a:latin typeface="Calibri"/>
+              </a:rPr>
+              <a:t>DEPLOY</a:t>
+            </a:r>
+          </a:p>
+        </p:txBody>
+      </p:sp>
+      <p:sp>
+        <p:nvSpPr>
+          <p:cNvPr id="7" name="Rectangle 6"/>
+          <p:cNvSpPr/>
+          <p:nvPr/>
+        </p:nvSpPr>
+        <p:spPr>
+          <a:xfrm>
+            <a:off x="4297680" y="1051560"/>
+            <a:ext cx="3566160" cy="914400"/>
+          </a:xfrm>
+          <a:prstGeom prst="rect">
+            <a:avLst/>
+          </a:prstGeom>
+          <a:solidFill>
+            <a:srgbClr val="0D9488"/>
+          </a:solidFill>
+          <a:ln>
+            <a:noFill/>
+          </a:ln>
+        </p:spPr>
+        <p:style>
+          <a:lnRef idx="1">
+            <a:schemeClr val="accent1"/>
+          </a:lnRef>
+          <a:fillRef idx="3">
+            <a:schemeClr val="accent1"/>
+          </a:fillRef>
+          <a:effectRef idx="2">
+            <a:schemeClr val="accent1"/>
+          </a:effectRef>
+          <a:fontRef idx="minor">
+            <a:schemeClr val="lt1"/>
+          </a:fontRef>
+        </p:style>
+        <p:txBody>
+          <a:bodyPr rtlCol="0" anchor="ctr"/>
+          <a:lstStyle/>
+          <a:p>
+            <a:pPr algn="ctr"/>
+          </a:p>
+        </p:txBody>
+      </p:sp>
+      <p:sp>
+        <p:nvSpPr>
+          <p:cNvPr id="8" name="TextBox 7"/>
+          <p:cNvSpPr txBox="1"/>
+          <p:nvPr/>
+        </p:nvSpPr>
+        <p:spPr>
+          <a:xfrm>
+            <a:off x="4297680" y="1234440"/>
+            <a:ext cx="3566160" cy="548640"/>
+          </a:xfrm>
+          <a:prstGeom prst="rect">
+            <a:avLst/>
+          </a:prstGeom>
+          <a:noFill/>
+        </p:spPr>
+        <p:txBody>
+          <a:bodyPr wrap="square">
+            <a:spAutoFit/>
+          </a:bodyPr>
+          <a:lstStyle/>
+          <a:p>
+            <a:pPr algn="ctr"/>
+            <a:r>
+              <a:rPr sz="2000" b="1">
+                <a:solidFill>
                   <a:srgbClr val="FFFFFF"/>
                 </a:solidFill>
                 <a:latin typeface="Calibri"/>
               </a:rPr>
-              <a:t>HOLD  ← our call</a:t>
+              <a:t>ITERATE  ← our call</a:t>
+            </a:r>
+          </a:p>
+        </p:txBody>
+      </p:sp>
+      <p:sp>
+        <p:nvSpPr>
+          <p:cNvPr id="9" name="Rectangle 8"/>
+          <p:cNvSpPr/>
+          <p:nvPr/>
+        </p:nvSpPr>
+        <p:spPr>
+          <a:xfrm>
+            <a:off x="8092440" y="1051560"/>
+            <a:ext cx="3566160" cy="914400"/>
+          </a:xfrm>
+          <a:prstGeom prst="rect">
+            <a:avLst/>
+          </a:prstGeom>
+          <a:solidFill>
+            <a:srgbClr val="FFFFFF"/>
+          </a:solidFill>
+          <a:ln>
+            <a:noFill/>
+          </a:ln>
+        </p:spPr>
+        <p:style>
+          <a:lnRef idx="1">
+            <a:schemeClr val="accent1"/>
+          </a:lnRef>
+          <a:fillRef idx="3">
+            <a:schemeClr val="accent1"/>
+          </a:fillRef>
+          <a:effectRef idx="2">
+            <a:schemeClr val="accent1"/>
+          </a:effectRef>
+          <a:fontRef idx="minor">
+            <a:schemeClr val="lt1"/>
+          </a:fontRef>
+        </p:style>
+        <p:txBody>
+          <a:bodyPr rtlCol="0" anchor="ctr"/>
+          <a:lstStyle/>
+          <a:p>
+            <a:pPr algn="ctr"/>
+          </a:p>
+        </p:txBody>
+      </p:sp>
+      <p:sp>
+        <p:nvSpPr>
+          <p:cNvPr id="10" name="TextBox 9"/>
+          <p:cNvSpPr txBox="1"/>
+          <p:nvPr/>
+        </p:nvSpPr>
+        <p:spPr>
+          <a:xfrm>
+            <a:off x="8092440" y="1234440"/>
+            <a:ext cx="3566160" cy="548640"/>
+          </a:xfrm>
+          <a:prstGeom prst="rect">
+            <a:avLst/>
+          </a:prstGeom>
+          <a:noFill/>
+        </p:spPr>
+        <p:txBody>
+          <a:bodyPr wrap="square">
+            <a:spAutoFit/>
+          </a:bodyPr>
+          <a:lstStyle/>
+          <a:p>
+            <a:pPr algn="ctr"/>
+            <a:r>
+              <a:rPr sz="2000" b="1">
+                <a:solidFill>
+                  <a:srgbClr val="5C6B7A"/>
+                </a:solidFill>
+                <a:latin typeface="Calibri"/>
+              </a:rPr>
+              <a:t>HOLD</a:t>
             </a:r>
           </a:p>
         </p:txBody>
@@ -7540,7 +8721,7 @@
         <p:spPr>
           <a:xfrm>
             <a:off x="502920" y="2286000"/>
-            <a:ext cx="11155680" cy="3200400"/>
+            <a:ext cx="11155680" cy="3474720"/>
           </a:xfrm>
           <a:prstGeom prst="rect">
             <a:avLst/>
@@ -7565,7 +8746,7 @@
                 </a:solidFill>
                 <a:latin typeface="Calibri"/>
               </a:rPr>
-              <a:t>Why HOLD (do not deploy as a translator)</a:t>
+              <a:t>Why iterate (not deploy yet — and not give up)</a:t>
             </a:r>
           </a:p>
           <a:p>
@@ -7581,7 +8762,7 @@
                 </a:solidFill>
                 <a:latin typeface="Calibri"/>
               </a:rPr>
-              <a:t>• Primary human accuracy fell: base 48% → tuned 28% (English→slang 60% → 20%).</a:t>
+              <a:t>• Real win to keep: abstain on junk 10% → 100%.</a:t>
             </a:r>
           </a:p>
           <a:p>
@@ -7597,7 +8778,7 @@
                 </a:solidFill>
                 <a:latin typeface="Calibri"/>
               </a:rPr>
-              <a:t>• Slang→English flat at 37%; not enough lift to ship.</a:t>
+              <a:t>• Human translate accuracy fell overall (48% → 28%); English→slang 60% → 20% (acronym soup).</a:t>
             </a:r>
           </a:p>
           <a:p>
@@ -7613,7 +8794,7 @@
                 </a:solidFill>
                 <a:latin typeface="Calibri"/>
               </a:rPr>
-              <a:t>• Keep the abstain win (10% → 100% on junk) — that part is worth retaining.</a:t>
+              <a:t>• Slang→English flat at 37% — gap still open; task is hard (slide 6), so we keep improving.</a:t>
             </a:r>
           </a:p>
           <a:p>
@@ -7645,7 +8826,7 @@
                 </a:solidFill>
                 <a:latin typeface="Calibri"/>
               </a:rPr>
-              <a:t>If we continue (offline iterate)</a:t>
+              <a:t>Next steps</a:t>
             </a:r>
           </a:p>
           <a:p>
@@ -7661,7 +8842,23 @@
                 </a:solidFill>
                 <a:latin typeface="Calibri"/>
               </a:rPr>
-              <a:t>Fix English→slang data + decode; re-freeze eval; re-grade before any deploy claim.</a:t>
+              <a:t>Looser decode + less acronym-heavy data; more natural English→slang pairs; re-grade.</a:t>
+            </a:r>
+          </a:p>
+          <a:p>
+            <a:pPr>
+              <a:spcAft>
+                <a:spcPts val="400"/>
+              </a:spcAft>
+            </a:pPr>
+            <a:r>
+              <a:rPr sz="1500" b="0">
+                <a:solidFill>
+                  <a:srgbClr val="1A2B3C"/>
+                </a:solidFill>
+                <a:latin typeface="Calibri"/>
+              </a:rPr>
+              <a:t>Optional: short Gradio demo of abstain / one good slang→English example.</a:t>
             </a:r>
           </a:p>
         </p:txBody>
@@ -7675,7 +8872,7 @@
         <p:spPr>
           <a:xfrm>
             <a:off x="457200" y="6492240"/>
-            <a:ext cx="7315200" cy="274320"/>
+            <a:ext cx="8229600" cy="274320"/>
           </a:xfrm>
           <a:prstGeom prst="rect">
             <a:avLst/>
@@ -7709,8 +8906,8 @@
         </p:nvSpPr>
         <p:spPr>
           <a:xfrm>
-            <a:off x="10515600" y="6492240"/>
-            <a:ext cx="1188720" cy="274320"/>
+            <a:off x="10332720" y="6492240"/>
+            <a:ext cx="1371600" cy="274320"/>
           </a:xfrm>
           <a:prstGeom prst="rect">
             <a:avLst/>
@@ -7731,7 +8928,7 @@
                 </a:solidFill>
                 <a:latin typeface="Calibri"/>
               </a:rPr>
-              <a:t>6 / 6</a:t>
+              <a:t>7 / 7</a:t>
             </a:r>
           </a:p>
         </p:txBody>

</xml_diff>

<commit_message>
Update final recommendation slide in presentation deck
Co-authored-by: Cursor <cursoragent@cursor.com>
</commit_message>
<xml_diff>
--- a/docs/Group2_GenZ_Slang_Translator_Slides.pptx
+++ b/docs/Group2_GenZ_Slang_Translator_Slides.pptx
@@ -5,15 +5,15 @@
     <p:sldMasterId id="2147483648" r:id="rId1"/>
   </p:sldMasterIdLst>
   <p:sldIdLst>
-    <p:sldId id="256" r:id="rId7"/>
-    <p:sldId id="257" r:id="rId8"/>
-    <p:sldId id="258" r:id="rId9"/>
-    <p:sldId id="259" r:id="rId10"/>
-    <p:sldId id="260" r:id="rId11"/>
-    <p:sldId id="261" r:id="rId12"/>
-    <p:sldId id="262" r:id="rId13"/>
+    <p:sldId id="256" r:id="rId2"/>
+    <p:sldId id="257" r:id="rId3"/>
+    <p:sldId id="258" r:id="rId4"/>
+    <p:sldId id="259" r:id="rId5"/>
+    <p:sldId id="260" r:id="rId6"/>
+    <p:sldId id="261" r:id="rId7"/>
+    <p:sldId id="262" r:id="rId8"/>
   </p:sldIdLst>
-  <p:sldSz cx="12191695" cy="6858000" type="screen4x3"/>
+  <p:sldSz cx="12192000" cy="6858000"/>
   <p:notesSz cx="6858000" cy="9144000"/>
   <p:defaultTextStyle>
     <a:defPPr>
@@ -110,6 +110,22 @@
       </a:defRPr>
     </a:lvl9pPr>
   </p:defaultTextStyle>
+  <p:extLst>
+    <p:ext uri="{EFAFB233-063F-42B5-8137-9DF3F51BA10A}">
+      <p15:sldGuideLst xmlns:p15="http://schemas.microsoft.com/office/powerpoint/2012/main">
+        <p15:guide id="1" orient="horz" pos="2160">
+          <p15:clr>
+            <a:srgbClr val="A4A3A4"/>
+          </p15:clr>
+        </p15:guide>
+        <p15:guide id="2" pos="2880">
+          <p15:clr>
+            <a:srgbClr val="A4A3A4"/>
+          </p15:clr>
+        </p15:guide>
+      </p15:sldGuideLst>
+    </p:ext>
+  </p:extLst>
 </p:presentation>
 </file>
 
@@ -151,10 +167,9 @@
           <a:lstStyle/>
           <a:p>
             <a:r>
-              <a:rPr lang="en-US" smtClean="0"/>
+              <a:rPr lang="en-US"/>
               <a:t>Click to edit Master title style</a:t>
             </a:r>
-            <a:endParaRPr lang="en-US"/>
           </a:p>
         </p:txBody>
       </p:sp>
@@ -270,10 +285,9 @@
           </a:lstStyle>
           <a:p>
             <a:r>
-              <a:rPr lang="en-US" smtClean="0"/>
+              <a:rPr lang="en-US"/>
               <a:t>Click to edit Master subtitle style</a:t>
             </a:r>
-            <a:endParaRPr lang="en-US"/>
           </a:p>
         </p:txBody>
       </p:sp>
@@ -294,7 +308,7 @@
           <a:p>
             <a:fld id="{5BCAD085-E8A6-8845-BD4E-CB4CCA059FC4}" type="datetimeFigureOut">
               <a:rPr lang="en-US" smtClean="0"/>
-              <a:t>1/27/13</a:t>
+              <a:t>2026-07-17</a:t>
             </a:fld>
             <a:endParaRPr lang="en-US"/>
           </a:p>
@@ -388,10 +402,9 @@
           <a:lstStyle/>
           <a:p>
             <a:r>
-              <a:rPr lang="en-US" smtClean="0"/>
+              <a:rPr lang="en-US"/>
               <a:t>Click to edit Master title style</a:t>
             </a:r>
-            <a:endParaRPr lang="en-US"/>
           </a:p>
         </p:txBody>
       </p:sp>
@@ -412,38 +425,37 @@
           <a:p>
             <a:pPr lvl="0"/>
             <a:r>
-              <a:rPr lang="en-US" smtClean="0"/>
+              <a:rPr lang="en-US"/>
               <a:t>Click to edit Master text styles</a:t>
             </a:r>
           </a:p>
           <a:p>
             <a:pPr lvl="1"/>
             <a:r>
-              <a:rPr lang="en-US" smtClean="0"/>
+              <a:rPr lang="en-US"/>
               <a:t>Second level</a:t>
             </a:r>
           </a:p>
           <a:p>
             <a:pPr lvl="2"/>
             <a:r>
-              <a:rPr lang="en-US" smtClean="0"/>
+              <a:rPr lang="en-US"/>
               <a:t>Third level</a:t>
             </a:r>
           </a:p>
           <a:p>
             <a:pPr lvl="3"/>
             <a:r>
-              <a:rPr lang="en-US" smtClean="0"/>
+              <a:rPr lang="en-US"/>
               <a:t>Fourth level</a:t>
             </a:r>
           </a:p>
           <a:p>
             <a:pPr lvl="4"/>
             <a:r>
-              <a:rPr lang="en-US" smtClean="0"/>
+              <a:rPr lang="en-US"/>
               <a:t>Fifth level</a:t>
             </a:r>
-            <a:endParaRPr lang="en-US"/>
           </a:p>
         </p:txBody>
       </p:sp>
@@ -464,7 +476,7 @@
           <a:p>
             <a:fld id="{5BCAD085-E8A6-8845-BD4E-CB4CCA059FC4}" type="datetimeFigureOut">
               <a:rPr lang="en-US" smtClean="0"/>
-              <a:t>1/27/13</a:t>
+              <a:t>2026-07-17</a:t>
             </a:fld>
             <a:endParaRPr lang="en-US"/>
           </a:p>
@@ -563,10 +575,9 @@
           <a:lstStyle/>
           <a:p>
             <a:r>
-              <a:rPr lang="en-US" smtClean="0"/>
+              <a:rPr lang="en-US"/>
               <a:t>Click to edit Master title style</a:t>
             </a:r>
-            <a:endParaRPr lang="en-US"/>
           </a:p>
         </p:txBody>
       </p:sp>
@@ -592,38 +603,37 @@
           <a:p>
             <a:pPr lvl="0"/>
             <a:r>
-              <a:rPr lang="en-US" smtClean="0"/>
+              <a:rPr lang="en-US"/>
               <a:t>Click to edit Master text styles</a:t>
             </a:r>
           </a:p>
           <a:p>
             <a:pPr lvl="1"/>
             <a:r>
-              <a:rPr lang="en-US" smtClean="0"/>
+              <a:rPr lang="en-US"/>
               <a:t>Second level</a:t>
             </a:r>
           </a:p>
           <a:p>
             <a:pPr lvl="2"/>
             <a:r>
-              <a:rPr lang="en-US" smtClean="0"/>
+              <a:rPr lang="en-US"/>
               <a:t>Third level</a:t>
             </a:r>
           </a:p>
           <a:p>
             <a:pPr lvl="3"/>
             <a:r>
-              <a:rPr lang="en-US" smtClean="0"/>
+              <a:rPr lang="en-US"/>
               <a:t>Fourth level</a:t>
             </a:r>
           </a:p>
           <a:p>
             <a:pPr lvl="4"/>
             <a:r>
-              <a:rPr lang="en-US" smtClean="0"/>
+              <a:rPr lang="en-US"/>
               <a:t>Fifth level</a:t>
             </a:r>
-            <a:endParaRPr lang="en-US"/>
           </a:p>
         </p:txBody>
       </p:sp>
@@ -644,7 +654,7 @@
           <a:p>
             <a:fld id="{5BCAD085-E8A6-8845-BD4E-CB4CCA059FC4}" type="datetimeFigureOut">
               <a:rPr lang="en-US" smtClean="0"/>
-              <a:t>1/27/13</a:t>
+              <a:t>2026-07-17</a:t>
             </a:fld>
             <a:endParaRPr lang="en-US"/>
           </a:p>
@@ -738,10 +748,9 @@
           <a:lstStyle/>
           <a:p>
             <a:r>
-              <a:rPr lang="en-US" smtClean="0"/>
+              <a:rPr lang="en-US"/>
               <a:t>Click to edit Master title style</a:t>
             </a:r>
-            <a:endParaRPr lang="en-US"/>
           </a:p>
         </p:txBody>
       </p:sp>
@@ -762,38 +771,37 @@
           <a:p>
             <a:pPr lvl="0"/>
             <a:r>
-              <a:rPr lang="en-US" smtClean="0"/>
+              <a:rPr lang="en-US"/>
               <a:t>Click to edit Master text styles</a:t>
             </a:r>
           </a:p>
           <a:p>
             <a:pPr lvl="1"/>
             <a:r>
-              <a:rPr lang="en-US" smtClean="0"/>
+              <a:rPr lang="en-US"/>
               <a:t>Second level</a:t>
             </a:r>
           </a:p>
           <a:p>
             <a:pPr lvl="2"/>
             <a:r>
-              <a:rPr lang="en-US" smtClean="0"/>
+              <a:rPr lang="en-US"/>
               <a:t>Third level</a:t>
             </a:r>
           </a:p>
           <a:p>
             <a:pPr lvl="3"/>
             <a:r>
-              <a:rPr lang="en-US" smtClean="0"/>
+              <a:rPr lang="en-US"/>
               <a:t>Fourth level</a:t>
             </a:r>
           </a:p>
           <a:p>
             <a:pPr lvl="4"/>
             <a:r>
-              <a:rPr lang="en-US" smtClean="0"/>
+              <a:rPr lang="en-US"/>
               <a:t>Fifth level</a:t>
             </a:r>
-            <a:endParaRPr lang="en-US"/>
           </a:p>
         </p:txBody>
       </p:sp>
@@ -814,7 +822,7 @@
           <a:p>
             <a:fld id="{5BCAD085-E8A6-8845-BD4E-CB4CCA059FC4}" type="datetimeFigureOut">
               <a:rPr lang="en-US" smtClean="0"/>
-              <a:t>1/27/13</a:t>
+              <a:t>2026-07-17</a:t>
             </a:fld>
             <a:endParaRPr lang="en-US"/>
           </a:p>
@@ -917,10 +925,9 @@
           </a:lstStyle>
           <a:p>
             <a:r>
-              <a:rPr lang="en-US" smtClean="0"/>
+              <a:rPr lang="en-US"/>
               <a:t>Click to edit Master title style</a:t>
             </a:r>
-            <a:endParaRPr lang="en-US"/>
           </a:p>
         </p:txBody>
       </p:sp>
@@ -1037,7 +1044,7 @@
           <a:p>
             <a:pPr lvl="0"/>
             <a:r>
-              <a:rPr lang="en-US" smtClean="0"/>
+              <a:rPr lang="en-US"/>
               <a:t>Click to edit Master text styles</a:t>
             </a:r>
           </a:p>
@@ -1060,7 +1067,7 @@
           <a:p>
             <a:fld id="{5BCAD085-E8A6-8845-BD4E-CB4CCA059FC4}" type="datetimeFigureOut">
               <a:rPr lang="en-US" smtClean="0"/>
-              <a:t>1/27/13</a:t>
+              <a:t>2026-07-17</a:t>
             </a:fld>
             <a:endParaRPr lang="en-US"/>
           </a:p>
@@ -1154,10 +1161,9 @@
           <a:lstStyle/>
           <a:p>
             <a:r>
-              <a:rPr lang="en-US" smtClean="0"/>
+              <a:rPr lang="en-US"/>
               <a:t>Click to edit Master title style</a:t>
             </a:r>
-            <a:endParaRPr lang="en-US"/>
           </a:p>
         </p:txBody>
       </p:sp>
@@ -1211,38 +1217,37 @@
           <a:p>
             <a:pPr lvl="0"/>
             <a:r>
-              <a:rPr lang="en-US" smtClean="0"/>
+              <a:rPr lang="en-US"/>
               <a:t>Click to edit Master text styles</a:t>
             </a:r>
           </a:p>
           <a:p>
             <a:pPr lvl="1"/>
             <a:r>
-              <a:rPr lang="en-US" smtClean="0"/>
+              <a:rPr lang="en-US"/>
               <a:t>Second level</a:t>
             </a:r>
           </a:p>
           <a:p>
             <a:pPr lvl="2"/>
             <a:r>
-              <a:rPr lang="en-US" smtClean="0"/>
+              <a:rPr lang="en-US"/>
               <a:t>Third level</a:t>
             </a:r>
           </a:p>
           <a:p>
             <a:pPr lvl="3"/>
             <a:r>
-              <a:rPr lang="en-US" smtClean="0"/>
+              <a:rPr lang="en-US"/>
               <a:t>Fourth level</a:t>
             </a:r>
           </a:p>
           <a:p>
             <a:pPr lvl="4"/>
             <a:r>
-              <a:rPr lang="en-US" smtClean="0"/>
+              <a:rPr lang="en-US"/>
               <a:t>Fifth level</a:t>
             </a:r>
-            <a:endParaRPr lang="en-US"/>
           </a:p>
         </p:txBody>
       </p:sp>
@@ -1296,38 +1301,37 @@
           <a:p>
             <a:pPr lvl="0"/>
             <a:r>
-              <a:rPr lang="en-US" smtClean="0"/>
+              <a:rPr lang="en-US"/>
               <a:t>Click to edit Master text styles</a:t>
             </a:r>
           </a:p>
           <a:p>
             <a:pPr lvl="1"/>
             <a:r>
-              <a:rPr lang="en-US" smtClean="0"/>
+              <a:rPr lang="en-US"/>
               <a:t>Second level</a:t>
             </a:r>
           </a:p>
           <a:p>
             <a:pPr lvl="2"/>
             <a:r>
-              <a:rPr lang="en-US" smtClean="0"/>
+              <a:rPr lang="en-US"/>
               <a:t>Third level</a:t>
             </a:r>
           </a:p>
           <a:p>
             <a:pPr lvl="3"/>
             <a:r>
-              <a:rPr lang="en-US" smtClean="0"/>
+              <a:rPr lang="en-US"/>
               <a:t>Fourth level</a:t>
             </a:r>
           </a:p>
           <a:p>
             <a:pPr lvl="4"/>
             <a:r>
-              <a:rPr lang="en-US" smtClean="0"/>
+              <a:rPr lang="en-US"/>
               <a:t>Fifth level</a:t>
             </a:r>
-            <a:endParaRPr lang="en-US"/>
           </a:p>
         </p:txBody>
       </p:sp>
@@ -1348,7 +1352,7 @@
           <a:p>
             <a:fld id="{5BCAD085-E8A6-8845-BD4E-CB4CCA059FC4}" type="datetimeFigureOut">
               <a:rPr lang="en-US" smtClean="0"/>
-              <a:t>1/27/13</a:t>
+              <a:t>2026-07-17</a:t>
             </a:fld>
             <a:endParaRPr lang="en-US"/>
           </a:p>
@@ -1446,10 +1450,9 @@
           </a:lstStyle>
           <a:p>
             <a:r>
-              <a:rPr lang="en-US" smtClean="0"/>
+              <a:rPr lang="en-US"/>
               <a:t>Click to edit Master title style</a:t>
             </a:r>
-            <a:endParaRPr lang="en-US"/>
           </a:p>
         </p:txBody>
       </p:sp>
@@ -1512,7 +1515,7 @@
           <a:p>
             <a:pPr lvl="0"/>
             <a:r>
-              <a:rPr lang="en-US" smtClean="0"/>
+              <a:rPr lang="en-US"/>
               <a:t>Click to edit Master text styles</a:t>
             </a:r>
           </a:p>
@@ -1568,38 +1571,37 @@
           <a:p>
             <a:pPr lvl="0"/>
             <a:r>
-              <a:rPr lang="en-US" smtClean="0"/>
+              <a:rPr lang="en-US"/>
               <a:t>Click to edit Master text styles</a:t>
             </a:r>
           </a:p>
           <a:p>
             <a:pPr lvl="1"/>
             <a:r>
-              <a:rPr lang="en-US" smtClean="0"/>
+              <a:rPr lang="en-US"/>
               <a:t>Second level</a:t>
             </a:r>
           </a:p>
           <a:p>
             <a:pPr lvl="2"/>
             <a:r>
-              <a:rPr lang="en-US" smtClean="0"/>
+              <a:rPr lang="en-US"/>
               <a:t>Third level</a:t>
             </a:r>
           </a:p>
           <a:p>
             <a:pPr lvl="3"/>
             <a:r>
-              <a:rPr lang="en-US" smtClean="0"/>
+              <a:rPr lang="en-US"/>
               <a:t>Fourth level</a:t>
             </a:r>
           </a:p>
           <a:p>
             <a:pPr lvl="4"/>
             <a:r>
-              <a:rPr lang="en-US" smtClean="0"/>
+              <a:rPr lang="en-US"/>
               <a:t>Fifth level</a:t>
             </a:r>
-            <a:endParaRPr lang="en-US"/>
           </a:p>
         </p:txBody>
       </p:sp>
@@ -1662,7 +1664,7 @@
           <a:p>
             <a:pPr lvl="0"/>
             <a:r>
-              <a:rPr lang="en-US" smtClean="0"/>
+              <a:rPr lang="en-US"/>
               <a:t>Click to edit Master text styles</a:t>
             </a:r>
           </a:p>
@@ -1718,38 +1720,37 @@
           <a:p>
             <a:pPr lvl="0"/>
             <a:r>
-              <a:rPr lang="en-US" smtClean="0"/>
+              <a:rPr lang="en-US"/>
               <a:t>Click to edit Master text styles</a:t>
             </a:r>
           </a:p>
           <a:p>
             <a:pPr lvl="1"/>
             <a:r>
-              <a:rPr lang="en-US" smtClean="0"/>
+              <a:rPr lang="en-US"/>
               <a:t>Second level</a:t>
             </a:r>
           </a:p>
           <a:p>
             <a:pPr lvl="2"/>
             <a:r>
-              <a:rPr lang="en-US" smtClean="0"/>
+              <a:rPr lang="en-US"/>
               <a:t>Third level</a:t>
             </a:r>
           </a:p>
           <a:p>
             <a:pPr lvl="3"/>
             <a:r>
-              <a:rPr lang="en-US" smtClean="0"/>
+              <a:rPr lang="en-US"/>
               <a:t>Fourth level</a:t>
             </a:r>
           </a:p>
           <a:p>
             <a:pPr lvl="4"/>
             <a:r>
-              <a:rPr lang="en-US" smtClean="0"/>
+              <a:rPr lang="en-US"/>
               <a:t>Fifth level</a:t>
             </a:r>
-            <a:endParaRPr lang="en-US"/>
           </a:p>
         </p:txBody>
       </p:sp>
@@ -1770,7 +1771,7 @@
           <a:p>
             <a:fld id="{5BCAD085-E8A6-8845-BD4E-CB4CCA059FC4}" type="datetimeFigureOut">
               <a:rPr lang="en-US" smtClean="0"/>
-              <a:t>1/27/13</a:t>
+              <a:t>2026-07-17</a:t>
             </a:fld>
             <a:endParaRPr lang="en-US"/>
           </a:p>
@@ -1864,10 +1865,9 @@
           <a:lstStyle/>
           <a:p>
             <a:r>
-              <a:rPr lang="en-US" smtClean="0"/>
+              <a:rPr lang="en-US"/>
               <a:t>Click to edit Master title style</a:t>
             </a:r>
-            <a:endParaRPr lang="en-US"/>
           </a:p>
         </p:txBody>
       </p:sp>
@@ -1888,7 +1888,7 @@
           <a:p>
             <a:fld id="{5BCAD085-E8A6-8845-BD4E-CB4CCA059FC4}" type="datetimeFigureOut">
               <a:rPr lang="en-US" smtClean="0"/>
-              <a:t>1/27/13</a:t>
+              <a:t>2026-07-17</a:t>
             </a:fld>
             <a:endParaRPr lang="en-US"/>
           </a:p>
@@ -1983,7 +1983,7 @@
           <a:p>
             <a:fld id="{5BCAD085-E8A6-8845-BD4E-CB4CCA059FC4}" type="datetimeFigureOut">
               <a:rPr lang="en-US" smtClean="0"/>
-              <a:t>1/27/13</a:t>
+              <a:t>2026-07-17</a:t>
             </a:fld>
             <a:endParaRPr lang="en-US"/>
           </a:p>
@@ -2086,10 +2086,9 @@
           </a:lstStyle>
           <a:p>
             <a:r>
-              <a:rPr lang="en-US" smtClean="0"/>
+              <a:rPr lang="en-US"/>
               <a:t>Click to edit Master title style</a:t>
             </a:r>
-            <a:endParaRPr lang="en-US"/>
           </a:p>
         </p:txBody>
       </p:sp>
@@ -2143,38 +2142,37 @@
           <a:p>
             <a:pPr lvl="0"/>
             <a:r>
-              <a:rPr lang="en-US" smtClean="0"/>
+              <a:rPr lang="en-US"/>
               <a:t>Click to edit Master text styles</a:t>
             </a:r>
           </a:p>
           <a:p>
             <a:pPr lvl="1"/>
             <a:r>
-              <a:rPr lang="en-US" smtClean="0"/>
+              <a:rPr lang="en-US"/>
               <a:t>Second level</a:t>
             </a:r>
           </a:p>
           <a:p>
             <a:pPr lvl="2"/>
             <a:r>
-              <a:rPr lang="en-US" smtClean="0"/>
+              <a:rPr lang="en-US"/>
               <a:t>Third level</a:t>
             </a:r>
           </a:p>
           <a:p>
             <a:pPr lvl="3"/>
             <a:r>
-              <a:rPr lang="en-US" smtClean="0"/>
+              <a:rPr lang="en-US"/>
               <a:t>Fourth level</a:t>
             </a:r>
           </a:p>
           <a:p>
             <a:pPr lvl="4"/>
             <a:r>
-              <a:rPr lang="en-US" smtClean="0"/>
+              <a:rPr lang="en-US"/>
               <a:t>Fifth level</a:t>
             </a:r>
-            <a:endParaRPr lang="en-US"/>
           </a:p>
         </p:txBody>
       </p:sp>
@@ -2237,7 +2235,7 @@
           <a:p>
             <a:pPr lvl="0"/>
             <a:r>
-              <a:rPr lang="en-US" smtClean="0"/>
+              <a:rPr lang="en-US"/>
               <a:t>Click to edit Master text styles</a:t>
             </a:r>
           </a:p>
@@ -2260,7 +2258,7 @@
           <a:p>
             <a:fld id="{5BCAD085-E8A6-8845-BD4E-CB4CCA059FC4}" type="datetimeFigureOut">
               <a:rPr lang="en-US" smtClean="0"/>
-              <a:t>1/27/13</a:t>
+              <a:t>2026-07-17</a:t>
             </a:fld>
             <a:endParaRPr lang="en-US"/>
           </a:p>
@@ -2363,10 +2361,9 @@
           </a:lstStyle>
           <a:p>
             <a:r>
-              <a:rPr lang="en-US" smtClean="0"/>
+              <a:rPr lang="en-US"/>
               <a:t>Click to edit Master title style</a:t>
             </a:r>
-            <a:endParaRPr lang="en-US"/>
           </a:p>
         </p:txBody>
       </p:sp>
@@ -2490,7 +2487,7 @@
           <a:p>
             <a:pPr lvl="0"/>
             <a:r>
-              <a:rPr lang="en-US" smtClean="0"/>
+              <a:rPr lang="en-US"/>
               <a:t>Click to edit Master text styles</a:t>
             </a:r>
           </a:p>
@@ -2513,7 +2510,7 @@
           <a:p>
             <a:fld id="{5BCAD085-E8A6-8845-BD4E-CB4CCA059FC4}" type="datetimeFigureOut">
               <a:rPr lang="en-US" smtClean="0"/>
-              <a:t>1/27/13</a:t>
+              <a:t>2026-07-17</a:t>
             </a:fld>
             <a:endParaRPr lang="en-US"/>
           </a:p>
@@ -2622,10 +2619,9 @@
           <a:lstStyle/>
           <a:p>
             <a:r>
-              <a:rPr lang="en-US" smtClean="0"/>
+              <a:rPr lang="en-US"/>
               <a:t>Click to edit Master title style</a:t>
             </a:r>
-            <a:endParaRPr lang="en-US"/>
           </a:p>
         </p:txBody>
       </p:sp>
@@ -2656,38 +2652,37 @@
           <a:p>
             <a:pPr lvl="0"/>
             <a:r>
-              <a:rPr lang="en-US" smtClean="0"/>
+              <a:rPr lang="en-US"/>
               <a:t>Click to edit Master text styles</a:t>
             </a:r>
           </a:p>
           <a:p>
             <a:pPr lvl="1"/>
             <a:r>
-              <a:rPr lang="en-US" smtClean="0"/>
+              <a:rPr lang="en-US"/>
               <a:t>Second level</a:t>
             </a:r>
           </a:p>
           <a:p>
             <a:pPr lvl="2"/>
             <a:r>
-              <a:rPr lang="en-US" smtClean="0"/>
+              <a:rPr lang="en-US"/>
               <a:t>Third level</a:t>
             </a:r>
           </a:p>
           <a:p>
             <a:pPr lvl="3"/>
             <a:r>
-              <a:rPr lang="en-US" smtClean="0"/>
+              <a:rPr lang="en-US"/>
               <a:t>Fourth level</a:t>
             </a:r>
           </a:p>
           <a:p>
             <a:pPr lvl="4"/>
             <a:r>
-              <a:rPr lang="en-US" smtClean="0"/>
+              <a:rPr lang="en-US"/>
               <a:t>Fifth level</a:t>
             </a:r>
-            <a:endParaRPr lang="en-US"/>
           </a:p>
         </p:txBody>
       </p:sp>
@@ -2726,7 +2721,7 @@
           <a:p>
             <a:fld id="{5BCAD085-E8A6-8845-BD4E-CB4CCA059FC4}" type="datetimeFigureOut">
               <a:rPr lang="en-US" smtClean="0"/>
-              <a:t>1/27/13</a:t>
+              <a:t>2026-07-17</a:t>
             </a:fld>
             <a:endParaRPr lang="en-US"/>
           </a:p>
@@ -3085,7 +3080,7 @@
 </file>
 
 <file path=ppt/slides/slide1.xml><?xml version="1.0" encoding="utf-8"?>
-<p:sld xmlns:a="http://schemas.openxmlformats.org/drawingml/2006/main" xmlns:p="http://schemas.openxmlformats.org/presentationml/2006/main" xmlns:r="http://schemas.openxmlformats.org/officeDocument/2006/relationships">
+<p:sld xmlns:a="http://schemas.openxmlformats.org/drawingml/2006/main" xmlns:r="http://schemas.openxmlformats.org/officeDocument/2006/relationships" xmlns:p="http://schemas.openxmlformats.org/presentationml/2006/main">
   <p:cSld>
     <p:spTree>
       <p:nvGrpSpPr>
@@ -3093,7 +3088,14 @@
         <p:cNvGrpSpPr/>
         <p:nvPr/>
       </p:nvGrpSpPr>
-      <p:grpSpPr/>
+      <p:grpSpPr>
+        <a:xfrm>
+          <a:off x="0" y="0"/>
+          <a:ext cx="0" cy="0"/>
+          <a:chOff x="0" y="0"/>
+          <a:chExt cx="0" cy="0"/>
+        </a:xfrm>
+      </p:grpSpPr>
       <p:sp>
         <p:nvSpPr>
           <p:cNvPr id="2" name="Rectangle 1"/>
@@ -3134,6 +3136,7 @@
           <a:lstStyle/>
           <a:p>
             <a:pPr algn="ctr"/>
+            <a:endParaRPr/>
           </a:p>
         </p:txBody>
       </p:sp>
@@ -3177,6 +3180,7 @@
           <a:lstStyle/>
           <a:p>
             <a:pPr algn="ctr"/>
+            <a:endParaRPr/>
           </a:p>
         </p:txBody>
       </p:sp>
@@ -3220,6 +3224,7 @@
           <a:lstStyle/>
           <a:p>
             <a:pPr algn="ctr"/>
+            <a:endParaRPr/>
           </a:p>
         </p:txBody>
       </p:sp>
@@ -3404,6 +3409,7 @@
           <a:lstStyle/>
           <a:p>
             <a:pPr algn="ctr"/>
+            <a:endParaRPr/>
           </a:p>
         </p:txBody>
       </p:sp>
@@ -3447,6 +3453,7 @@
           <a:lstStyle/>
           <a:p>
             <a:pPr algn="ctr"/>
+            <a:endParaRPr/>
           </a:p>
         </p:txBody>
       </p:sp>
@@ -3612,6 +3619,7 @@
           <a:lstStyle/>
           <a:p>
             <a:pPr algn="ctr"/>
+            <a:endParaRPr/>
           </a:p>
         </p:txBody>
       </p:sp>
@@ -3655,6 +3663,7 @@
           <a:lstStyle/>
           <a:p>
             <a:pPr algn="ctr"/>
+            <a:endParaRPr/>
           </a:p>
         </p:txBody>
       </p:sp>
@@ -3859,7 +3868,7 @@
 </file>
 
 <file path=ppt/slides/slide2.xml><?xml version="1.0" encoding="utf-8"?>
-<p:sld xmlns:a="http://schemas.openxmlformats.org/drawingml/2006/main" xmlns:p="http://schemas.openxmlformats.org/presentationml/2006/main" xmlns:r="http://schemas.openxmlformats.org/officeDocument/2006/relationships">
+<p:sld xmlns:a="http://schemas.openxmlformats.org/drawingml/2006/main" xmlns:r="http://schemas.openxmlformats.org/officeDocument/2006/relationships" xmlns:p="http://schemas.openxmlformats.org/presentationml/2006/main">
   <p:cSld>
     <p:spTree>
       <p:nvGrpSpPr>
@@ -3867,7 +3876,14 @@
         <p:cNvGrpSpPr/>
         <p:nvPr/>
       </p:nvGrpSpPr>
-      <p:grpSpPr/>
+      <p:grpSpPr>
+        <a:xfrm>
+          <a:off x="0" y="0"/>
+          <a:ext cx="0" cy="0"/>
+          <a:chOff x="0" y="0"/>
+          <a:chExt cx="0" cy="0"/>
+        </a:xfrm>
+      </p:grpSpPr>
       <p:sp>
         <p:nvSpPr>
           <p:cNvPr id="2" name="Rectangle 1"/>
@@ -3908,6 +3924,7 @@
           <a:lstStyle/>
           <a:p>
             <a:pPr algn="ctr"/>
+            <a:endParaRPr/>
           </a:p>
         </p:txBody>
       </p:sp>
@@ -3951,6 +3968,7 @@
           <a:lstStyle/>
           <a:p>
             <a:pPr algn="ctr"/>
+            <a:endParaRPr/>
           </a:p>
         </p:txBody>
       </p:sp>
@@ -4084,6 +4102,7 @@
           <a:lstStyle/>
           <a:p>
             <a:pPr algn="ctr"/>
+            <a:endParaRPr/>
           </a:p>
         </p:txBody>
       </p:sp>
@@ -4352,7 +4371,7 @@
 </file>
 
 <file path=ppt/slides/slide3.xml><?xml version="1.0" encoding="utf-8"?>
-<p:sld xmlns:a="http://schemas.openxmlformats.org/drawingml/2006/main" xmlns:p="http://schemas.openxmlformats.org/presentationml/2006/main" xmlns:r="http://schemas.openxmlformats.org/officeDocument/2006/relationships">
+<p:sld xmlns:a="http://schemas.openxmlformats.org/drawingml/2006/main" xmlns:r="http://schemas.openxmlformats.org/officeDocument/2006/relationships" xmlns:p="http://schemas.openxmlformats.org/presentationml/2006/main">
   <p:cSld>
     <p:spTree>
       <p:nvGrpSpPr>
@@ -4360,7 +4379,14 @@
         <p:cNvGrpSpPr/>
         <p:nvPr/>
       </p:nvGrpSpPr>
-      <p:grpSpPr/>
+      <p:grpSpPr>
+        <a:xfrm>
+          <a:off x="0" y="0"/>
+          <a:ext cx="0" cy="0"/>
+          <a:chOff x="0" y="0"/>
+          <a:chExt cx="0" cy="0"/>
+        </a:xfrm>
+      </p:grpSpPr>
       <p:sp>
         <p:nvSpPr>
           <p:cNvPr id="2" name="Rectangle 1"/>
@@ -4401,6 +4427,7 @@
           <a:lstStyle/>
           <a:p>
             <a:pPr algn="ctr"/>
+            <a:endParaRPr/>
           </a:p>
         </p:txBody>
       </p:sp>
@@ -4444,6 +4471,7 @@
           <a:lstStyle/>
           <a:p>
             <a:pPr algn="ctr"/>
+            <a:endParaRPr/>
           </a:p>
         </p:txBody>
       </p:sp>
@@ -4522,6 +4550,7 @@
           <a:lstStyle/>
           <a:p>
             <a:pPr algn="ctr"/>
+            <a:endParaRPr/>
           </a:p>
         </p:txBody>
       </p:sp>
@@ -4565,6 +4594,7 @@
           <a:lstStyle/>
           <a:p>
             <a:pPr algn="ctr"/>
+            <a:endParaRPr/>
           </a:p>
         </p:txBody>
       </p:sp>
@@ -4715,6 +4745,7 @@
           <a:lstStyle/>
           <a:p>
             <a:pPr algn="ctr"/>
+            <a:endParaRPr/>
           </a:p>
         </p:txBody>
       </p:sp>
@@ -4758,6 +4789,7 @@
           <a:lstStyle/>
           <a:p>
             <a:pPr algn="ctr"/>
+            <a:endParaRPr/>
           </a:p>
         </p:txBody>
       </p:sp>
@@ -4908,6 +4940,7 @@
           <a:lstStyle/>
           <a:p>
             <a:pPr algn="ctr"/>
+            <a:endParaRPr/>
           </a:p>
         </p:txBody>
       </p:sp>
@@ -4951,6 +4984,7 @@
           <a:lstStyle/>
           <a:p>
             <a:pPr algn="ctr"/>
+            <a:endParaRPr/>
           </a:p>
         </p:txBody>
       </p:sp>
@@ -5101,6 +5135,7 @@
           <a:lstStyle/>
           <a:p>
             <a:pPr algn="ctr"/>
+            <a:endParaRPr/>
           </a:p>
         </p:txBody>
       </p:sp>
@@ -5144,6 +5179,7 @@
           <a:lstStyle/>
           <a:p>
             <a:pPr algn="ctr"/>
+            <a:endParaRPr/>
           </a:p>
         </p:txBody>
       </p:sp>
@@ -5401,7 +5437,7 @@
 </file>
 
 <file path=ppt/slides/slide4.xml><?xml version="1.0" encoding="utf-8"?>
-<p:sld xmlns:a="http://schemas.openxmlformats.org/drawingml/2006/main" xmlns:p="http://schemas.openxmlformats.org/presentationml/2006/main" xmlns:r="http://schemas.openxmlformats.org/officeDocument/2006/relationships">
+<p:sld xmlns:a="http://schemas.openxmlformats.org/drawingml/2006/main" xmlns:r="http://schemas.openxmlformats.org/officeDocument/2006/relationships" xmlns:p="http://schemas.openxmlformats.org/presentationml/2006/main">
   <p:cSld>
     <p:spTree>
       <p:nvGrpSpPr>
@@ -5409,7 +5445,14 @@
         <p:cNvGrpSpPr/>
         <p:nvPr/>
       </p:nvGrpSpPr>
-      <p:grpSpPr/>
+      <p:grpSpPr>
+        <a:xfrm>
+          <a:off x="0" y="0"/>
+          <a:ext cx="0" cy="0"/>
+          <a:chOff x="0" y="0"/>
+          <a:chExt cx="0" cy="0"/>
+        </a:xfrm>
+      </p:grpSpPr>
       <p:sp>
         <p:nvSpPr>
           <p:cNvPr id="2" name="Rectangle 1"/>
@@ -5450,6 +5493,7 @@
           <a:lstStyle/>
           <a:p>
             <a:pPr algn="ctr"/>
+            <a:endParaRPr/>
           </a:p>
         </p:txBody>
       </p:sp>
@@ -5493,6 +5537,7 @@
           <a:lstStyle/>
           <a:p>
             <a:pPr algn="ctr"/>
+            <a:endParaRPr/>
           </a:p>
         </p:txBody>
       </p:sp>
@@ -5606,6 +5651,7 @@
           <a:lstStyle/>
           <a:p>
             <a:pPr algn="ctr"/>
+            <a:endParaRPr/>
           </a:p>
         </p:txBody>
       </p:sp>
@@ -5649,6 +5695,7 @@
           <a:lstStyle/>
           <a:p>
             <a:pPr algn="ctr"/>
+            <a:endParaRPr/>
           </a:p>
         </p:txBody>
       </p:sp>
@@ -5675,15 +5722,7 @@
           <a:lstStyle/>
           <a:p>
             <a:pPr algn="l"/>
-            <a:r>
-              <a:rPr sz="1500" b="1">
-                <a:solidFill>
-                  <a:srgbClr val="FFFFFF"/>
-                </a:solidFill>
-                <a:latin typeface="Calibri"/>
-              </a:rPr>
-              <a:t/>
-            </a:r>
+            <a:endParaRPr/>
           </a:p>
         </p:txBody>
       </p:sp>
@@ -5797,6 +5836,7 @@
           <a:lstStyle/>
           <a:p>
             <a:pPr algn="ctr"/>
+            <a:endParaRPr/>
           </a:p>
         </p:txBody>
       </p:sp>
@@ -5945,6 +5985,7 @@
           <a:lstStyle/>
           <a:p>
             <a:pPr algn="ctr"/>
+            <a:endParaRPr/>
           </a:p>
         </p:txBody>
       </p:sp>
@@ -6093,6 +6134,7 @@
           <a:lstStyle/>
           <a:p>
             <a:pPr algn="ctr"/>
+            <a:endParaRPr/>
           </a:p>
         </p:txBody>
       </p:sp>
@@ -6241,6 +6283,7 @@
           <a:lstStyle/>
           <a:p>
             <a:pPr algn="ctr"/>
+            <a:endParaRPr/>
           </a:p>
         </p:txBody>
       </p:sp>
@@ -6389,6 +6432,7 @@
           <a:lstStyle/>
           <a:p>
             <a:pPr algn="ctr"/>
+            <a:endParaRPr/>
           </a:p>
         </p:txBody>
       </p:sp>
@@ -6518,15 +6562,12 @@
                 <a:spcPts val="400"/>
               </a:spcAft>
             </a:pPr>
-            <a:r>
-              <a:rPr sz="1300" b="0">
-                <a:solidFill>
-                  <a:srgbClr val="5C6B7A"/>
-                </a:solidFill>
-                <a:latin typeface="Calibri"/>
-              </a:rPr>
-              <a:t/>
-            </a:r>
+            <a:endParaRPr sz="1300" b="0">
+              <a:solidFill>
+                <a:srgbClr val="5C6B7A"/>
+              </a:solidFill>
+              <a:latin typeface="Calibri"/>
+            </a:endParaRPr>
           </a:p>
           <a:p>
             <a:pPr>
@@ -6661,7 +6702,7 @@
 </file>
 
 <file path=ppt/slides/slide5.xml><?xml version="1.0" encoding="utf-8"?>
-<p:sld xmlns:a="http://schemas.openxmlformats.org/drawingml/2006/main" xmlns:p="http://schemas.openxmlformats.org/presentationml/2006/main" xmlns:r="http://schemas.openxmlformats.org/officeDocument/2006/relationships">
+<p:sld xmlns:a="http://schemas.openxmlformats.org/drawingml/2006/main" xmlns:r="http://schemas.openxmlformats.org/officeDocument/2006/relationships" xmlns:p="http://schemas.openxmlformats.org/presentationml/2006/main">
   <p:cSld>
     <p:spTree>
       <p:nvGrpSpPr>
@@ -6669,7 +6710,14 @@
         <p:cNvGrpSpPr/>
         <p:nvPr/>
       </p:nvGrpSpPr>
-      <p:grpSpPr/>
+      <p:grpSpPr>
+        <a:xfrm>
+          <a:off x="0" y="0"/>
+          <a:ext cx="0" cy="0"/>
+          <a:chOff x="0" y="0"/>
+          <a:chExt cx="0" cy="0"/>
+        </a:xfrm>
+      </p:grpSpPr>
       <p:sp>
         <p:nvSpPr>
           <p:cNvPr id="2" name="Rectangle 1"/>
@@ -6710,6 +6758,7 @@
           <a:lstStyle/>
           <a:p>
             <a:pPr algn="ctr"/>
+            <a:endParaRPr/>
           </a:p>
         </p:txBody>
       </p:sp>
@@ -6753,6 +6802,7 @@
           <a:lstStyle/>
           <a:p>
             <a:pPr algn="ctr"/>
+            <a:endParaRPr/>
           </a:p>
         </p:txBody>
       </p:sp>
@@ -6831,6 +6881,7 @@
           <a:lstStyle/>
           <a:p>
             <a:pPr algn="ctr"/>
+            <a:endParaRPr/>
           </a:p>
         </p:txBody>
       </p:sp>
@@ -6980,6 +7031,7 @@
           <a:lstStyle/>
           <a:p>
             <a:pPr algn="ctr"/>
+            <a:endParaRPr/>
           </a:p>
         </p:txBody>
       </p:sp>
@@ -7168,7 +7220,7 @@
 </file>
 
 <file path=ppt/slides/slide6.xml><?xml version="1.0" encoding="utf-8"?>
-<p:sld xmlns:a="http://schemas.openxmlformats.org/drawingml/2006/main" xmlns:p="http://schemas.openxmlformats.org/presentationml/2006/main" xmlns:r="http://schemas.openxmlformats.org/officeDocument/2006/relationships">
+<p:sld xmlns:a="http://schemas.openxmlformats.org/drawingml/2006/main" xmlns:r="http://schemas.openxmlformats.org/officeDocument/2006/relationships" xmlns:p="http://schemas.openxmlformats.org/presentationml/2006/main">
   <p:cSld>
     <p:spTree>
       <p:nvGrpSpPr>
@@ -7176,7 +7228,14 @@
         <p:cNvGrpSpPr/>
         <p:nvPr/>
       </p:nvGrpSpPr>
-      <p:grpSpPr/>
+      <p:grpSpPr>
+        <a:xfrm>
+          <a:off x="0" y="0"/>
+          <a:ext cx="0" cy="0"/>
+          <a:chOff x="0" y="0"/>
+          <a:chExt cx="0" cy="0"/>
+        </a:xfrm>
+      </p:grpSpPr>
       <p:sp>
         <p:nvSpPr>
           <p:cNvPr id="2" name="Rectangle 1"/>
@@ -7217,6 +7276,7 @@
           <a:lstStyle/>
           <a:p>
             <a:pPr algn="ctr"/>
+            <a:endParaRPr/>
           </a:p>
         </p:txBody>
       </p:sp>
@@ -7260,6 +7320,7 @@
           <a:lstStyle/>
           <a:p>
             <a:pPr algn="ctr"/>
+            <a:endParaRPr/>
           </a:p>
         </p:txBody>
       </p:sp>
@@ -7373,6 +7434,7 @@
           <a:lstStyle/>
           <a:p>
             <a:pPr algn="ctr"/>
+            <a:endParaRPr/>
           </a:p>
         </p:txBody>
       </p:sp>
@@ -7416,6 +7478,7 @@
           <a:lstStyle/>
           <a:p>
             <a:pPr algn="ctr"/>
+            <a:endParaRPr/>
           </a:p>
         </p:txBody>
       </p:sp>
@@ -7529,6 +7592,7 @@
           <a:lstStyle/>
           <a:p>
             <a:pPr algn="ctr"/>
+            <a:endParaRPr/>
           </a:p>
         </p:txBody>
       </p:sp>
@@ -7572,6 +7636,7 @@
           <a:lstStyle/>
           <a:p>
             <a:pPr algn="ctr"/>
+            <a:endParaRPr/>
           </a:p>
         </p:txBody>
       </p:sp>
@@ -7685,6 +7750,7 @@
           <a:lstStyle/>
           <a:p>
             <a:pPr algn="ctr"/>
+            <a:endParaRPr/>
           </a:p>
         </p:txBody>
       </p:sp>
@@ -7728,6 +7794,7 @@
           <a:lstStyle/>
           <a:p>
             <a:pPr algn="ctr"/>
+            <a:endParaRPr/>
           </a:p>
         </p:txBody>
       </p:sp>
@@ -7841,6 +7908,7 @@
           <a:lstStyle/>
           <a:p>
             <a:pPr algn="ctr"/>
+            <a:endParaRPr/>
           </a:p>
         </p:txBody>
       </p:sp>
@@ -7884,6 +7952,7 @@
           <a:lstStyle/>
           <a:p>
             <a:pPr algn="ctr"/>
+            <a:endParaRPr/>
           </a:p>
         </p:txBody>
       </p:sp>
@@ -7997,6 +8066,7 @@
           <a:lstStyle/>
           <a:p>
             <a:pPr algn="ctr"/>
+            <a:endParaRPr/>
           </a:p>
         </p:txBody>
       </p:sp>
@@ -8040,6 +8110,7 @@
           <a:lstStyle/>
           <a:p>
             <a:pPr algn="ctr"/>
+            <a:endParaRPr/>
           </a:p>
         </p:txBody>
       </p:sp>
@@ -8153,6 +8224,7 @@
           <a:lstStyle/>
           <a:p>
             <a:pPr algn="ctr"/>
+            <a:endParaRPr/>
           </a:p>
         </p:txBody>
       </p:sp>
@@ -8196,6 +8268,7 @@
           <a:lstStyle/>
           <a:p>
             <a:pPr algn="ctr"/>
+            <a:endParaRPr/>
           </a:p>
         </p:txBody>
       </p:sp>
@@ -8348,7 +8421,7 @@
 </file>
 
 <file path=ppt/slides/slide7.xml><?xml version="1.0" encoding="utf-8"?>
-<p:sld xmlns:a="http://schemas.openxmlformats.org/drawingml/2006/main" xmlns:p="http://schemas.openxmlformats.org/presentationml/2006/main" xmlns:r="http://schemas.openxmlformats.org/officeDocument/2006/relationships">
+<p:sld xmlns:a="http://schemas.openxmlformats.org/drawingml/2006/main" xmlns:r="http://schemas.openxmlformats.org/officeDocument/2006/relationships" xmlns:p="http://schemas.openxmlformats.org/presentationml/2006/main">
   <p:cSld>
     <p:spTree>
       <p:nvGrpSpPr>
@@ -8356,7 +8429,14 @@
         <p:cNvGrpSpPr/>
         <p:nvPr/>
       </p:nvGrpSpPr>
-      <p:grpSpPr/>
+      <p:grpSpPr>
+        <a:xfrm>
+          <a:off x="0" y="0"/>
+          <a:ext cx="0" cy="0"/>
+          <a:chOff x="0" y="0"/>
+          <a:chExt cx="0" cy="0"/>
+        </a:xfrm>
+      </p:grpSpPr>
       <p:sp>
         <p:nvSpPr>
           <p:cNvPr id="2" name="Rectangle 1"/>
@@ -8397,6 +8477,7 @@
           <a:lstStyle/>
           <a:p>
             <a:pPr algn="ctr"/>
+            <a:endParaRPr/>
           </a:p>
         </p:txBody>
       </p:sp>
@@ -8440,6 +8521,7 @@
           <a:lstStyle/>
           <a:p>
             <a:pPr algn="ctr"/>
+            <a:endParaRPr/>
           </a:p>
         </p:txBody>
       </p:sp>
@@ -8518,6 +8600,7 @@
           <a:lstStyle/>
           <a:p>
             <a:pPr algn="ctr"/>
+            <a:endParaRPr/>
           </a:p>
         </p:txBody>
       </p:sp>
@@ -8596,6 +8679,7 @@
           <a:lstStyle/>
           <a:p>
             <a:pPr algn="ctr"/>
+            <a:endParaRPr/>
           </a:p>
         </p:txBody>
       </p:sp>
@@ -8674,6 +8758,7 @@
           <a:lstStyle/>
           <a:p>
             <a:pPr algn="ctr"/>
+            <a:endParaRPr/>
           </a:p>
         </p:txBody>
       </p:sp>
@@ -8803,15 +8888,12 @@
                 <a:spcPts val="400"/>
               </a:spcAft>
             </a:pPr>
-            <a:r>
-              <a:rPr sz="1500" b="0">
-                <a:solidFill>
-                  <a:srgbClr val="1A2B3C"/>
-                </a:solidFill>
-                <a:latin typeface="Calibri"/>
-              </a:rPr>
-              <a:t/>
-            </a:r>
+            <a:endParaRPr sz="1500" b="0">
+              <a:solidFill>
+                <a:srgbClr val="1A2B3C"/>
+              </a:solidFill>
+              <a:latin typeface="Calibri"/>
+            </a:endParaRPr>
           </a:p>
           <a:p>
             <a:pPr>
@@ -8933,6 +9015,37 @@
           </a:p>
         </p:txBody>
       </p:sp>
+      <p:pic>
+        <p:nvPicPr>
+          <p:cNvPr id="15" name="Picture 14">
+            <a:extLst>
+              <a:ext uri="{FF2B5EF4-FFF2-40B4-BE49-F238E27FC236}">
+                <a16:creationId xmlns:a16="http://schemas.microsoft.com/office/drawing/2014/main" id="{13E19EAF-DC38-0BC7-1F5C-20AC29CC4F3B}"/>
+              </a:ext>
+            </a:extLst>
+          </p:cNvPr>
+          <p:cNvPicPr>
+            <a:picLocks noChangeAspect="1"/>
+          </p:cNvPicPr>
+          <p:nvPr/>
+        </p:nvPicPr>
+        <p:blipFill>
+          <a:blip r:embed="rId2"/>
+          <a:srcRect l="25273" r="26571"/>
+          <a:stretch>
+            <a:fillRect/>
+          </a:stretch>
+        </p:blipFill>
+        <p:spPr>
+          <a:xfrm>
+            <a:off x="8180317" y="2104666"/>
+            <a:ext cx="3390406" cy="4224289"/>
+          </a:xfrm>
+          <a:prstGeom prst="rect">
+            <a:avLst/>
+          </a:prstGeom>
+        </p:spPr>
+      </p:pic>
     </p:spTree>
   </p:cSld>
   <p:clrMapOvr>

</xml_diff>